<commit_message>
Fix two-digit feature-card numbers wrapping in the pptx
Widen the number badge for 2-digit numbers and disable text wrap so numbers
like 10–17 stay on one line instead of stacking vertically.

Co-Authored-By: Claude Opus 4.8 <noreply@anthropic.com>
Claude-Session: https://claude.ai/code/session_01AHnuqKvAeatevgbRBy647K
</commit_message>
<xml_diff>
--- a/baton-pass-takt-proposal.pptx
+++ b/baton-pass-takt-proposal.pptx
@@ -6325,7 +6325,7 @@
           <a:ln/>
         </p:spPr>
         <p:txBody>
-          <a:bodyPr wrap="square" rtlCol="0" anchor="ctr"/>
+          <a:bodyPr wrap="none" lIns="0" tIns="0" rIns="0" bIns="0" rtlCol="0" anchor="ctr"/>
           <a:lstStyle/>
           <a:p>
             <a:pPr algn="ctr" indent="0" marL="0">
@@ -6354,8 +6354,8 @@
         </p:nvSpPr>
         <p:spPr>
           <a:xfrm>
-            <a:off x="1005840" y="1792224"/>
-            <a:ext cx="4773168" cy="365760"/>
+            <a:off x="1060704" y="1792224"/>
+            <a:ext cx="4718304" cy="365760"/>
           </a:xfrm>
           <a:prstGeom prst="rect">
             <a:avLst/>
@@ -6599,7 +6599,7 @@
           <a:ln/>
         </p:spPr>
         <p:txBody>
-          <a:bodyPr wrap="square" rtlCol="0" anchor="ctr"/>
+          <a:bodyPr wrap="none" lIns="0" tIns="0" rIns="0" bIns="0" rtlCol="0" anchor="ctr"/>
           <a:lstStyle/>
           <a:p>
             <a:pPr algn="ctr" indent="0" marL="0">
@@ -6628,8 +6628,8 @@
         </p:nvSpPr>
         <p:spPr>
           <a:xfrm>
-            <a:off x="6793992" y="1792224"/>
-            <a:ext cx="4773168" cy="365760"/>
+            <a:off x="6848856" y="1792224"/>
+            <a:ext cx="4718304" cy="365760"/>
           </a:xfrm>
           <a:prstGeom prst="rect">
             <a:avLst/>
@@ -6873,7 +6873,7 @@
           <a:ln/>
         </p:spPr>
         <p:txBody>
-          <a:bodyPr wrap="square" rtlCol="0" anchor="ctr"/>
+          <a:bodyPr wrap="none" lIns="0" tIns="0" rIns="0" bIns="0" rtlCol="0" anchor="ctr"/>
           <a:lstStyle/>
           <a:p>
             <a:pPr algn="ctr" indent="0" marL="0">
@@ -6902,8 +6902,8 @@
         </p:nvSpPr>
         <p:spPr>
           <a:xfrm>
-            <a:off x="1005840" y="3017520"/>
-            <a:ext cx="4773168" cy="365760"/>
+            <a:off x="1060704" y="3017520"/>
+            <a:ext cx="4718304" cy="365760"/>
           </a:xfrm>
           <a:prstGeom prst="rect">
             <a:avLst/>
@@ -7147,7 +7147,7 @@
           <a:ln/>
         </p:spPr>
         <p:txBody>
-          <a:bodyPr wrap="square" rtlCol="0" anchor="ctr"/>
+          <a:bodyPr wrap="none" lIns="0" tIns="0" rIns="0" bIns="0" rtlCol="0" anchor="ctr"/>
           <a:lstStyle/>
           <a:p>
             <a:pPr algn="ctr" indent="0" marL="0">
@@ -7176,8 +7176,8 @@
         </p:nvSpPr>
         <p:spPr>
           <a:xfrm>
-            <a:off x="6793992" y="3017520"/>
-            <a:ext cx="4773168" cy="365760"/>
+            <a:off x="6848856" y="3017520"/>
+            <a:ext cx="4718304" cy="365760"/>
           </a:xfrm>
           <a:prstGeom prst="rect">
             <a:avLst/>
@@ -7435,7 +7435,7 @@
           <a:ln/>
         </p:spPr>
         <p:txBody>
-          <a:bodyPr wrap="square" rtlCol="0" anchor="ctr"/>
+          <a:bodyPr wrap="none" lIns="0" tIns="0" rIns="0" bIns="0" rtlCol="0" anchor="ctr"/>
           <a:lstStyle/>
           <a:p>
             <a:pPr algn="ctr" indent="0" marL="0">
@@ -7464,8 +7464,8 @@
         </p:nvSpPr>
         <p:spPr>
           <a:xfrm>
-            <a:off x="1005840" y="4242816"/>
-            <a:ext cx="4773168" cy="365760"/>
+            <a:off x="1060704" y="4242816"/>
+            <a:ext cx="4718304" cy="365760"/>
           </a:xfrm>
           <a:prstGeom prst="rect">
             <a:avLst/>
@@ -7723,7 +7723,7 @@
           <a:ln/>
         </p:spPr>
         <p:txBody>
-          <a:bodyPr wrap="square" rtlCol="0" anchor="ctr"/>
+          <a:bodyPr wrap="none" lIns="0" tIns="0" rIns="0" bIns="0" rtlCol="0" anchor="ctr"/>
           <a:lstStyle/>
           <a:p>
             <a:pPr algn="ctr" indent="0" marL="0">
@@ -7752,8 +7752,8 @@
         </p:nvSpPr>
         <p:spPr>
           <a:xfrm>
-            <a:off x="6793992" y="4242816"/>
-            <a:ext cx="4773168" cy="365760"/>
+            <a:off x="6848856" y="4242816"/>
+            <a:ext cx="4718304" cy="365760"/>
           </a:xfrm>
           <a:prstGeom prst="rect">
             <a:avLst/>
@@ -8011,7 +8011,7 @@
           <a:ln/>
         </p:spPr>
         <p:txBody>
-          <a:bodyPr wrap="square" rtlCol="0" anchor="ctr"/>
+          <a:bodyPr wrap="none" lIns="0" tIns="0" rIns="0" bIns="0" rtlCol="0" anchor="ctr"/>
           <a:lstStyle/>
           <a:p>
             <a:pPr algn="ctr" indent="0" marL="0">
@@ -8040,8 +8040,8 @@
         </p:nvSpPr>
         <p:spPr>
           <a:xfrm>
-            <a:off x="1005840" y="5468112"/>
-            <a:ext cx="4773168" cy="365760"/>
+            <a:off x="1060704" y="5468112"/>
+            <a:ext cx="4718304" cy="365760"/>
           </a:xfrm>
           <a:prstGeom prst="rect">
             <a:avLst/>
@@ -8299,7 +8299,7 @@
           <a:ln/>
         </p:spPr>
         <p:txBody>
-          <a:bodyPr wrap="square" rtlCol="0" anchor="ctr"/>
+          <a:bodyPr wrap="none" lIns="0" tIns="0" rIns="0" bIns="0" rtlCol="0" anchor="ctr"/>
           <a:lstStyle/>
           <a:p>
             <a:pPr algn="ctr" indent="0" marL="0">
@@ -8328,8 +8328,8 @@
         </p:nvSpPr>
         <p:spPr>
           <a:xfrm>
-            <a:off x="6793992" y="5468112"/>
-            <a:ext cx="4773168" cy="365760"/>
+            <a:off x="6848856" y="5468112"/>
+            <a:ext cx="4718304" cy="365760"/>
           </a:xfrm>
           <a:prstGeom prst="rect">
             <a:avLst/>
@@ -8834,7 +8834,7 @@
           <a:ln/>
         </p:spPr>
         <p:txBody>
-          <a:bodyPr wrap="square" rtlCol="0" anchor="ctr"/>
+          <a:bodyPr wrap="none" lIns="0" tIns="0" rIns="0" bIns="0" rtlCol="0" anchor="ctr"/>
           <a:lstStyle/>
           <a:p>
             <a:pPr algn="ctr" indent="0" marL="0">
@@ -8863,8 +8863,8 @@
         </p:nvSpPr>
         <p:spPr>
           <a:xfrm>
-            <a:off x="1005840" y="1828800"/>
-            <a:ext cx="2874264" cy="365760"/>
+            <a:off x="1060704" y="1828800"/>
+            <a:ext cx="2819400" cy="365760"/>
           </a:xfrm>
           <a:prstGeom prst="rect">
             <a:avLst/>
@@ -9077,7 +9077,7 @@
         <p:spPr>
           <a:xfrm>
             <a:off x="4483608" y="1865376"/>
-            <a:ext cx="292608" cy="292608"/>
+            <a:ext cx="457200" cy="292608"/>
           </a:xfrm>
           <a:prstGeom prst="roundRect">
             <a:avLst>
@@ -9099,16 +9099,16 @@
         <p:spPr>
           <a:xfrm>
             <a:off x="4483608" y="1865376"/>
-            <a:ext cx="292608" cy="292608"/>
-          </a:xfrm>
-          <a:prstGeom prst="rect">
-            <a:avLst/>
-          </a:prstGeom>
-          <a:noFill/>
-          <a:ln/>
-        </p:spPr>
-        <p:txBody>
-          <a:bodyPr wrap="square" rtlCol="0" anchor="ctr"/>
+            <a:ext cx="457200" cy="292608"/>
+          </a:xfrm>
+          <a:prstGeom prst="rect">
+            <a:avLst/>
+          </a:prstGeom>
+          <a:noFill/>
+          <a:ln/>
+        </p:spPr>
+        <p:txBody>
+          <a:bodyPr wrap="none" lIns="0" tIns="0" rIns="0" bIns="0" rtlCol="0" anchor="ctr"/>
           <a:lstStyle/>
           <a:p>
             <a:pPr algn="ctr" indent="0" marL="0">
@@ -9137,8 +9137,8 @@
         </p:nvSpPr>
         <p:spPr>
           <a:xfrm>
-            <a:off x="4849368" y="1828800"/>
-            <a:ext cx="2874264" cy="365760"/>
+            <a:off x="5068824" y="1828800"/>
+            <a:ext cx="2654808" cy="365760"/>
           </a:xfrm>
           <a:prstGeom prst="rect">
             <a:avLst/>
@@ -9365,7 +9365,7 @@
         <p:spPr>
           <a:xfrm>
             <a:off x="8327136" y="1865376"/>
-            <a:ext cx="292608" cy="292608"/>
+            <a:ext cx="457200" cy="292608"/>
           </a:xfrm>
           <a:prstGeom prst="roundRect">
             <a:avLst>
@@ -9387,16 +9387,16 @@
         <p:spPr>
           <a:xfrm>
             <a:off x="8327136" y="1865376"/>
-            <a:ext cx="292608" cy="292608"/>
-          </a:xfrm>
-          <a:prstGeom prst="rect">
-            <a:avLst/>
-          </a:prstGeom>
-          <a:noFill/>
-          <a:ln/>
-        </p:spPr>
-        <p:txBody>
-          <a:bodyPr wrap="square" rtlCol="0" anchor="ctr"/>
+            <a:ext cx="457200" cy="292608"/>
+          </a:xfrm>
+          <a:prstGeom prst="rect">
+            <a:avLst/>
+          </a:prstGeom>
+          <a:noFill/>
+          <a:ln/>
+        </p:spPr>
+        <p:txBody>
+          <a:bodyPr wrap="none" lIns="0" tIns="0" rIns="0" bIns="0" rtlCol="0" anchor="ctr"/>
           <a:lstStyle/>
           <a:p>
             <a:pPr algn="ctr" indent="0" marL="0">
@@ -9425,8 +9425,8 @@
         </p:nvSpPr>
         <p:spPr>
           <a:xfrm>
-            <a:off x="8692896" y="1828800"/>
-            <a:ext cx="2874264" cy="365760"/>
+            <a:off x="8912352" y="1828800"/>
+            <a:ext cx="2654808" cy="365760"/>
           </a:xfrm>
           <a:prstGeom prst="rect">
             <a:avLst/>
@@ -9653,7 +9653,7 @@
         <p:spPr>
           <a:xfrm>
             <a:off x="640080" y="3465576"/>
-            <a:ext cx="292608" cy="292608"/>
+            <a:ext cx="457200" cy="292608"/>
           </a:xfrm>
           <a:prstGeom prst="roundRect">
             <a:avLst>
@@ -9675,16 +9675,16 @@
         <p:spPr>
           <a:xfrm>
             <a:off x="640080" y="3465576"/>
-            <a:ext cx="292608" cy="292608"/>
-          </a:xfrm>
-          <a:prstGeom prst="rect">
-            <a:avLst/>
-          </a:prstGeom>
-          <a:noFill/>
-          <a:ln/>
-        </p:spPr>
-        <p:txBody>
-          <a:bodyPr wrap="square" rtlCol="0" anchor="ctr"/>
+            <a:ext cx="457200" cy="292608"/>
+          </a:xfrm>
+          <a:prstGeom prst="rect">
+            <a:avLst/>
+          </a:prstGeom>
+          <a:noFill/>
+          <a:ln/>
+        </p:spPr>
+        <p:txBody>
+          <a:bodyPr wrap="none" lIns="0" tIns="0" rIns="0" bIns="0" rtlCol="0" anchor="ctr"/>
           <a:lstStyle/>
           <a:p>
             <a:pPr algn="ctr" indent="0" marL="0">
@@ -9713,8 +9713,8 @@
         </p:nvSpPr>
         <p:spPr>
           <a:xfrm>
-            <a:off x="1005840" y="3429000"/>
-            <a:ext cx="2874264" cy="365760"/>
+            <a:off x="1225296" y="3429000"/>
+            <a:ext cx="2654808" cy="365760"/>
           </a:xfrm>
           <a:prstGeom prst="rect">
             <a:avLst/>
@@ -9941,7 +9941,7 @@
         <p:spPr>
           <a:xfrm>
             <a:off x="4483608" y="3465576"/>
-            <a:ext cx="292608" cy="292608"/>
+            <a:ext cx="457200" cy="292608"/>
           </a:xfrm>
           <a:prstGeom prst="roundRect">
             <a:avLst>
@@ -9963,16 +9963,16 @@
         <p:spPr>
           <a:xfrm>
             <a:off x="4483608" y="3465576"/>
-            <a:ext cx="292608" cy="292608"/>
-          </a:xfrm>
-          <a:prstGeom prst="rect">
-            <a:avLst/>
-          </a:prstGeom>
-          <a:noFill/>
-          <a:ln/>
-        </p:spPr>
-        <p:txBody>
-          <a:bodyPr wrap="square" rtlCol="0" anchor="ctr"/>
+            <a:ext cx="457200" cy="292608"/>
+          </a:xfrm>
+          <a:prstGeom prst="rect">
+            <a:avLst/>
+          </a:prstGeom>
+          <a:noFill/>
+          <a:ln/>
+        </p:spPr>
+        <p:txBody>
+          <a:bodyPr wrap="none" lIns="0" tIns="0" rIns="0" bIns="0" rtlCol="0" anchor="ctr"/>
           <a:lstStyle/>
           <a:p>
             <a:pPr algn="ctr" indent="0" marL="0">
@@ -10001,8 +10001,8 @@
         </p:nvSpPr>
         <p:spPr>
           <a:xfrm>
-            <a:off x="4849368" y="3429000"/>
-            <a:ext cx="2874264" cy="365760"/>
+            <a:off x="5068824" y="3429000"/>
+            <a:ext cx="2654808" cy="365760"/>
           </a:xfrm>
           <a:prstGeom prst="rect">
             <a:avLst/>
@@ -10229,7 +10229,7 @@
         <p:spPr>
           <a:xfrm>
             <a:off x="8327136" y="3465576"/>
-            <a:ext cx="292608" cy="292608"/>
+            <a:ext cx="457200" cy="292608"/>
           </a:xfrm>
           <a:prstGeom prst="roundRect">
             <a:avLst>
@@ -10251,16 +10251,16 @@
         <p:spPr>
           <a:xfrm>
             <a:off x="8327136" y="3465576"/>
-            <a:ext cx="292608" cy="292608"/>
-          </a:xfrm>
-          <a:prstGeom prst="rect">
-            <a:avLst/>
-          </a:prstGeom>
-          <a:noFill/>
-          <a:ln/>
-        </p:spPr>
-        <p:txBody>
-          <a:bodyPr wrap="square" rtlCol="0" anchor="ctr"/>
+            <a:ext cx="457200" cy="292608"/>
+          </a:xfrm>
+          <a:prstGeom prst="rect">
+            <a:avLst/>
+          </a:prstGeom>
+          <a:noFill/>
+          <a:ln/>
+        </p:spPr>
+        <p:txBody>
+          <a:bodyPr wrap="none" lIns="0" tIns="0" rIns="0" bIns="0" rtlCol="0" anchor="ctr"/>
           <a:lstStyle/>
           <a:p>
             <a:pPr algn="ctr" indent="0" marL="0">
@@ -10289,8 +10289,8 @@
         </p:nvSpPr>
         <p:spPr>
           <a:xfrm>
-            <a:off x="8692896" y="3429000"/>
-            <a:ext cx="2874264" cy="365760"/>
+            <a:off x="8912352" y="3429000"/>
+            <a:ext cx="2654808" cy="365760"/>
           </a:xfrm>
           <a:prstGeom prst="rect">
             <a:avLst/>
@@ -10517,7 +10517,7 @@
         <p:spPr>
           <a:xfrm>
             <a:off x="640080" y="5065776"/>
-            <a:ext cx="292608" cy="292608"/>
+            <a:ext cx="457200" cy="292608"/>
           </a:xfrm>
           <a:prstGeom prst="roundRect">
             <a:avLst>
@@ -10539,16 +10539,16 @@
         <p:spPr>
           <a:xfrm>
             <a:off x="640080" y="5065776"/>
-            <a:ext cx="292608" cy="292608"/>
-          </a:xfrm>
-          <a:prstGeom prst="rect">
-            <a:avLst/>
-          </a:prstGeom>
-          <a:noFill/>
-          <a:ln/>
-        </p:spPr>
-        <p:txBody>
-          <a:bodyPr wrap="square" rtlCol="0" anchor="ctr"/>
+            <a:ext cx="457200" cy="292608"/>
+          </a:xfrm>
+          <a:prstGeom prst="rect">
+            <a:avLst/>
+          </a:prstGeom>
+          <a:noFill/>
+          <a:ln/>
+        </p:spPr>
+        <p:txBody>
+          <a:bodyPr wrap="none" lIns="0" tIns="0" rIns="0" bIns="0" rtlCol="0" anchor="ctr"/>
           <a:lstStyle/>
           <a:p>
             <a:pPr algn="ctr" indent="0" marL="0">
@@ -10577,8 +10577,8 @@
         </p:nvSpPr>
         <p:spPr>
           <a:xfrm>
-            <a:off x="1005840" y="5029200"/>
-            <a:ext cx="2874264" cy="365760"/>
+            <a:off x="1225296" y="5029200"/>
+            <a:ext cx="2654808" cy="365760"/>
           </a:xfrm>
           <a:prstGeom prst="rect">
             <a:avLst/>
@@ -10805,7 +10805,7 @@
         <p:spPr>
           <a:xfrm>
             <a:off x="4483608" y="5065776"/>
-            <a:ext cx="292608" cy="292608"/>
+            <a:ext cx="457200" cy="292608"/>
           </a:xfrm>
           <a:prstGeom prst="roundRect">
             <a:avLst>
@@ -10827,16 +10827,16 @@
         <p:spPr>
           <a:xfrm>
             <a:off x="4483608" y="5065776"/>
-            <a:ext cx="292608" cy="292608"/>
-          </a:xfrm>
-          <a:prstGeom prst="rect">
-            <a:avLst/>
-          </a:prstGeom>
-          <a:noFill/>
-          <a:ln/>
-        </p:spPr>
-        <p:txBody>
-          <a:bodyPr wrap="square" rtlCol="0" anchor="ctr"/>
+            <a:ext cx="457200" cy="292608"/>
+          </a:xfrm>
+          <a:prstGeom prst="rect">
+            <a:avLst/>
+          </a:prstGeom>
+          <a:noFill/>
+          <a:ln/>
+        </p:spPr>
+        <p:txBody>
+          <a:bodyPr wrap="none" lIns="0" tIns="0" rIns="0" bIns="0" rtlCol="0" anchor="ctr"/>
           <a:lstStyle/>
           <a:p>
             <a:pPr algn="ctr" indent="0" marL="0">
@@ -10865,8 +10865,8 @@
         </p:nvSpPr>
         <p:spPr>
           <a:xfrm>
-            <a:off x="4849368" y="5029200"/>
-            <a:ext cx="2874264" cy="365760"/>
+            <a:off x="5068824" y="5029200"/>
+            <a:ext cx="2654808" cy="365760"/>
           </a:xfrm>
           <a:prstGeom prst="rect">
             <a:avLst/>
@@ -11093,7 +11093,7 @@
         <p:spPr>
           <a:xfrm>
             <a:off x="8327136" y="5065776"/>
-            <a:ext cx="292608" cy="292608"/>
+            <a:ext cx="457200" cy="292608"/>
           </a:xfrm>
           <a:prstGeom prst="roundRect">
             <a:avLst>
@@ -11115,16 +11115,16 @@
         <p:spPr>
           <a:xfrm>
             <a:off x="8327136" y="5065776"/>
-            <a:ext cx="292608" cy="292608"/>
-          </a:xfrm>
-          <a:prstGeom prst="rect">
-            <a:avLst/>
-          </a:prstGeom>
-          <a:noFill/>
-          <a:ln/>
-        </p:spPr>
-        <p:txBody>
-          <a:bodyPr wrap="square" rtlCol="0" anchor="ctr"/>
+            <a:ext cx="457200" cy="292608"/>
+          </a:xfrm>
+          <a:prstGeom prst="rect">
+            <a:avLst/>
+          </a:prstGeom>
+          <a:noFill/>
+          <a:ln/>
+        </p:spPr>
+        <p:txBody>
+          <a:bodyPr wrap="none" lIns="0" tIns="0" rIns="0" bIns="0" rtlCol="0" anchor="ctr"/>
           <a:lstStyle/>
           <a:p>
             <a:pPr algn="ctr" indent="0" marL="0">
@@ -11153,8 +11153,8 @@
         </p:nvSpPr>
         <p:spPr>
           <a:xfrm>
-            <a:off x="8692896" y="5029200"/>
-            <a:ext cx="2874264" cy="365760"/>
+            <a:off x="8912352" y="5029200"/>
+            <a:ext cx="2654808" cy="365760"/>
           </a:xfrm>
           <a:prstGeom prst="rect">
             <a:avLst/>

</xml_diff>

<commit_message>
Add a monthly-cost visualization slide with plain-language explanation
New slide charts each feature's monthly fee as horizontal bars grouped by
cost driver (high = AI/external APIs, medium = storage/light AI, low =
storage/display only), with a middle-schooler-friendly analogy and a
reconciliation: per-feature total ≈ 7.5万 + KOKU maintenance 3–6万 = plan
monthly 10–20万. Added to both the HTML deck and the pptx.

Co-Authored-By: Claude Opus 4.8 <noreply@anthropic.com>
Claude-Session: https://claude.ai/code/session_01AHnuqKvAeatevgbRBy647K
</commit_message>
<xml_diff>
--- a/baton-pass-takt-proposal.pptx
+++ b/baton-pass-takt-proposal.pptx
@@ -16,9 +16,10 @@
     <p:sldId id="264" r:id="rId10"/>
     <p:sldId id="265" r:id="rId11"/>
     <p:sldId id="266" r:id="rId12"/>
+    <p:sldId id="267" r:id="rId13"/>
   </p:sldIdLst>
   <p:notesMasterIdLst>
-    <p:notesMasterId r:id="rId13"/>
+    <p:notesMasterId r:id="rId14"/>
   </p:notesMasterIdLst>
   <p:sldSz cx="12192000" cy="6858000"/>
   <p:notesSz cx="6858000" cy="12192000"/>
@@ -712,6 +713,94 @@
             <a:fld id="{F7021451-1387-4CA6-816F-3879F97B5CBC}" type="slidenum">
               <a:rPr lang="en-US"/>
               <a:t>11</a:t>
+            </a:fld>
+            <a:endParaRPr lang="en-US"/>
+          </a:p>
+        </p:txBody>
+      </p:sp>
+    </p:spTree>
+    <p:extLst>
+      <p:ext uri="{BB962C8B-B14F-4D97-AF65-F5344CB8AC3E}">
+        <p14:creationId xmlns:p14="http://schemas.microsoft.com/office/powerpoint/2010/main" val="1024086991"/>
+      </p:ext>
+    </p:extLst>
+  </p:cSld>
+  <p:clrMapOvr>
+    <a:masterClrMapping/>
+  </p:clrMapOvr>
+</p:notes>
+</file>
+
+<file path=ppt/notesSlides/notesSlide12.xml><?xml version="1.0" encoding="utf-8"?>
+<p:notes xmlns:a="http://schemas.openxmlformats.org/drawingml/2006/main" xmlns:r="http://schemas.openxmlformats.org/officeDocument/2006/relationships" xmlns:p="http://schemas.openxmlformats.org/presentationml/2006/main">
+  <p:cSld>
+    <p:spTree>
+      <p:nvGrpSpPr>
+        <p:cNvPr id="1" name=""/>
+        <p:cNvGrpSpPr/>
+        <p:nvPr/>
+      </p:nvGrpSpPr>
+      <p:grpSpPr>
+        <a:xfrm>
+          <a:off x="0" y="0"/>
+          <a:ext cx="0" cy="0"/>
+          <a:chOff x="0" y="0"/>
+          <a:chExt cx="0" cy="0"/>
+        </a:xfrm>
+      </p:grpSpPr>
+      <p:sp>
+        <p:nvSpPr>
+          <p:cNvPr id="2" name="Slide Image Placeholder 1"/>
+          <p:cNvSpPr>
+            <a:spLocks noGrp="1" noRot="1" noChangeAspect="1"/>
+          </p:cNvSpPr>
+          <p:nvPr>
+            <p:ph type="sldImg"/>
+          </p:nvPr>
+        </p:nvSpPr>
+        <p:spPr/>
+      </p:sp>
+      <p:sp>
+        <p:nvSpPr>
+          <p:cNvPr id="3" name="Notes Placeholder 2"/>
+          <p:cNvSpPr>
+            <a:spLocks noGrp="1"/>
+          </p:cNvSpPr>
+          <p:nvPr>
+            <p:ph type="body" idx="1"/>
+          </p:nvPr>
+        </p:nvSpPr>
+        <p:spPr/>
+        <p:txBody>
+          <a:bodyPr/>
+          <a:lstStyle/>
+          <a:p>
+            <a:r>
+              <a:rPr lang="en-US" dirty="0"/>
+              <a:t/>
+            </a:r>
+            <a:endParaRPr lang="en-US" dirty="0"/>
+          </a:p>
+        </p:txBody>
+      </p:sp>
+      <p:sp>
+        <p:nvSpPr>
+          <p:cNvPr id="4" name="Slide Number Placeholder 3"/>
+          <p:cNvSpPr>
+            <a:spLocks noGrp="1"/>
+          </p:cNvSpPr>
+          <p:nvPr>
+            <p:ph type="sldNum" sz="quarter" idx="10"/>
+          </p:nvPr>
+        </p:nvSpPr>
+        <p:spPr/>
+        <p:txBody>
+          <a:bodyPr/>
+          <a:lstStyle/>
+          <a:p>
+            <a:fld id="{F7021451-1387-4CA6-816F-3879F97B5CBC}" type="slidenum">
+              <a:rPr lang="en-US"/>
+              <a:t>12</a:t>
             </a:fld>
             <a:endParaRPr lang="en-US"/>
           </a:p>
@@ -2341,7 +2430,7 @@
                 <a:ea typeface="Yu Gothic" pitchFamily="34" charset="-122"/>
                 <a:cs typeface="Yu Gothic" pitchFamily="34" charset="-120"/>
               </a:rPr>
-              <a:t>04 · おすすめの進め方</a:t>
+              <a:t>04 · 費用（月額の可視化）</a:t>
             </a:r>
             <a:endParaRPr lang="en-US" sz="1100" dirty="0"/>
           </a:p>
@@ -2380,7 +2469,7 @@
                 <a:ea typeface="Yu Gothic" pitchFamily="34" charset="-122"/>
                 <a:cs typeface="Yu Gothic" pitchFamily="34" charset="-120"/>
               </a:rPr>
-              <a:t>まず土台。効果を確かめて、収益直結の順に足す</a:t>
+              <a:t>月額はどれくらい？ ─ 機能ごとの毎月の料金</a:t>
             </a:r>
             <a:endParaRPr lang="en-US" sz="2700" dirty="0"/>
           </a:p>
@@ -2388,14 +2477,63 @@
       </p:sp>
       <p:sp>
         <p:nvSpPr>
-          <p:cNvPr id="4" name="Text 2"/>
+          <p:cNvPr id="4" name="Shape 2"/>
           <p:cNvSpPr/>
           <p:nvPr/>
         </p:nvSpPr>
         <p:spPr>
           <a:xfrm>
             <a:off x="457200" y="1371600"/>
-            <a:ext cx="11247120" cy="320040"/>
+            <a:ext cx="11274552" cy="566928"/>
+          </a:xfrm>
+          <a:prstGeom prst="roundRect">
+            <a:avLst>
+              <a:gd name="adj" fmla="val 12903"/>
+            </a:avLst>
+          </a:prstGeom>
+          <a:solidFill>
+            <a:srgbClr val="FBEEE9"/>
+          </a:solidFill>
+          <a:ln w="12700">
+            <a:solidFill>
+              <a:srgbClr val="EBC7B8"/>
+            </a:solidFill>
+            <a:prstDash val="solid"/>
+          </a:ln>
+        </p:spPr>
+      </p:sp>
+      <p:sp>
+        <p:nvSpPr>
+          <p:cNvPr id="5" name="Shape 3"/>
+          <p:cNvSpPr/>
+          <p:nvPr/>
+        </p:nvSpPr>
+        <p:spPr>
+          <a:xfrm>
+            <a:off x="457200" y="1371600"/>
+            <a:ext cx="73152" cy="566928"/>
+          </a:xfrm>
+          <a:prstGeom prst="roundRect">
+            <a:avLst>
+              <a:gd name="adj" fmla="val 50000"/>
+            </a:avLst>
+          </a:prstGeom>
+          <a:solidFill>
+            <a:srgbClr val="D9542F"/>
+          </a:solidFill>
+          <a:ln/>
+        </p:spPr>
+      </p:sp>
+      <p:sp>
+        <p:nvSpPr>
+          <p:cNvPr id="6" name="Text 4"/>
+          <p:cNvSpPr/>
+          <p:nvPr/>
+        </p:nvSpPr>
+        <p:spPr>
+          <a:xfrm>
+            <a:off x="713232" y="1371600"/>
+            <a:ext cx="10817352" cy="566928"/>
           </a:xfrm>
           <a:prstGeom prst="rect">
             <a:avLst/>
@@ -2408,37 +2546,1338 @@
           <a:lstStyle/>
           <a:p>
             <a:pPr indent="0" marL="0">
-              <a:buNone/>
-            </a:pPr>
-            <a:r>
-              <a:rPr lang="en-US" sz="1350" dirty="0">
-                <a:solidFill>
-                  <a:srgbClr val="5D667C"/>
-                </a:solidFill>
-                <a:latin typeface="Yu Gothic" pitchFamily="34" charset="0"/>
-                <a:ea typeface="Yu Gothic" pitchFamily="34" charset="-122"/>
-                <a:cs typeface="Yu Gothic" pitchFamily="34" charset="-120"/>
-              </a:rPr>
-              <a:t>初期投資を抑えつつ、効果を確かめながら次を判断できます。</a:t>
-            </a:r>
-            <a:endParaRPr lang="en-US" sz="1350" dirty="0"/>
-          </a:p>
-        </p:txBody>
-      </p:sp>
-      <p:sp>
-        <p:nvSpPr>
-          <p:cNvPr id="5" name="Shape 3"/>
-          <p:cNvSpPr/>
-          <p:nvPr/>
-        </p:nvSpPr>
-        <p:spPr>
-          <a:xfrm>
-            <a:off x="457200" y="2148840"/>
-            <a:ext cx="2510028" cy="2286000"/>
+              <a:lnSpc>
+                <a:spcPct val="110000"/>
+              </a:lnSpc>
+              <a:buNone/>
+            </a:pPr>
+            <a:r>
+              <a:rPr lang="en-US" sz="1250" dirty="0">
+                <a:solidFill>
+                  <a:srgbClr val="17223B"/>
+                </a:solidFill>
+                <a:latin typeface="Yu Gothic" pitchFamily="34" charset="0"/>
+                <a:ea typeface="Yu Gothic" pitchFamily="34" charset="-122"/>
+                <a:cs typeface="Yu Gothic" pitchFamily="34" charset="-120"/>
+              </a:rPr>
+              <a:t>「月額」＝ 毎月動かし続けるための </a:t>
+            </a:r>
+            <a:pPr indent="0" marL="0">
+              <a:lnSpc>
+                <a:spcPct val="110000"/>
+              </a:lnSpc>
+              <a:buNone/>
+            </a:pPr>
+            <a:r>
+              <a:rPr lang="en-US" sz="1250" b="1" dirty="0">
+                <a:solidFill>
+                  <a:srgbClr val="B7431F"/>
+                </a:solidFill>
+                <a:latin typeface="Yu Gothic" pitchFamily="34" charset="0"/>
+                <a:ea typeface="Yu Gothic" pitchFamily="34" charset="-122"/>
+                <a:cs typeface="Yu Gothic" pitchFamily="34" charset="-120"/>
+              </a:rPr>
+              <a:t>“使い続け料”</a:t>
+            </a:r>
+            <a:pPr indent="0" marL="0">
+              <a:lnSpc>
+                <a:spcPct val="110000"/>
+              </a:lnSpc>
+              <a:buNone/>
+            </a:pPr>
+            <a:r>
+              <a:rPr lang="en-US" sz="1250" dirty="0">
+                <a:solidFill>
+                  <a:srgbClr val="17223B"/>
+                </a:solidFill>
+                <a:latin typeface="Yu Gothic" pitchFamily="34" charset="0"/>
+                <a:ea typeface="Yu Gothic" pitchFamily="34" charset="-122"/>
+                <a:cs typeface="Yu Gothic" pitchFamily="34" charset="-120"/>
+              </a:rPr>
+              <a:t>。スマホ代や電気代と同じで、</a:t>
+            </a:r>
+            <a:pPr indent="0" marL="0">
+              <a:lnSpc>
+                <a:spcPct val="110000"/>
+              </a:lnSpc>
+              <a:buNone/>
+            </a:pPr>
+            <a:r>
+              <a:rPr lang="en-US" sz="1250" b="1" dirty="0">
+                <a:solidFill>
+                  <a:srgbClr val="17223B"/>
+                </a:solidFill>
+                <a:latin typeface="Yu Gothic" pitchFamily="34" charset="0"/>
+                <a:ea typeface="Yu Gothic" pitchFamily="34" charset="-122"/>
+                <a:cs typeface="Yu Gothic" pitchFamily="34" charset="-120"/>
+              </a:rPr>
+              <a:t>たくさん使う機能ほど高く</a:t>
+            </a:r>
+            <a:pPr indent="0" marL="0">
+              <a:lnSpc>
+                <a:spcPct val="110000"/>
+              </a:lnSpc>
+              <a:buNone/>
+            </a:pPr>
+            <a:r>
+              <a:rPr lang="en-US" sz="1250" dirty="0">
+                <a:solidFill>
+                  <a:srgbClr val="17223B"/>
+                </a:solidFill>
+                <a:latin typeface="Yu Gothic" pitchFamily="34" charset="0"/>
+                <a:ea typeface="Yu Gothic" pitchFamily="34" charset="-122"/>
+                <a:cs typeface="Yu Gothic" pitchFamily="34" charset="-120"/>
+              </a:rPr>
+              <a:t>なります（棒が長いほど高い）。</a:t>
+            </a:r>
+            <a:endParaRPr lang="en-US" sz="1250" dirty="0"/>
+          </a:p>
+        </p:txBody>
+      </p:sp>
+      <p:sp>
+        <p:nvSpPr>
+          <p:cNvPr id="7" name="Shape 5"/>
+          <p:cNvSpPr/>
+          <p:nvPr/>
+        </p:nvSpPr>
+        <p:spPr>
+          <a:xfrm>
+            <a:off x="457200" y="2112264"/>
+            <a:ext cx="155448" cy="155448"/>
           </a:xfrm>
           <a:prstGeom prst="roundRect">
             <a:avLst>
-              <a:gd name="adj" fmla="val 4000"/>
+              <a:gd name="adj" fmla="val 23529"/>
+            </a:avLst>
+          </a:prstGeom>
+          <a:solidFill>
+            <a:srgbClr val="D9542F"/>
+          </a:solidFill>
+          <a:ln/>
+        </p:spPr>
+      </p:sp>
+      <p:sp>
+        <p:nvSpPr>
+          <p:cNvPr id="8" name="Text 6"/>
+          <p:cNvSpPr/>
+          <p:nvPr/>
+        </p:nvSpPr>
+        <p:spPr>
+          <a:xfrm>
+            <a:off x="713232" y="2057400"/>
+            <a:ext cx="11018520" cy="274320"/>
+          </a:xfrm>
+          <a:prstGeom prst="rect">
+            <a:avLst/>
+          </a:prstGeom>
+          <a:noFill/>
+          <a:ln/>
+        </p:spPr>
+        <p:txBody>
+          <a:bodyPr wrap="square" rtlCol="0" anchor="ctr"/>
+          <a:lstStyle/>
+          <a:p>
+            <a:pPr indent="0" marL="0">
+              <a:buNone/>
+            </a:pPr>
+            <a:r>
+              <a:rPr lang="en-US" sz="1200" b="1" dirty="0">
+                <a:solidFill>
+                  <a:srgbClr val="17223B"/>
+                </a:solidFill>
+                <a:latin typeface="Yu Gothic" pitchFamily="34" charset="0"/>
+                <a:ea typeface="Yu Gothic" pitchFamily="34" charset="-122"/>
+                <a:cs typeface="Yu Gothic" pitchFamily="34" charset="-120"/>
+              </a:rPr>
+              <a:t>高い：AIや外部サービス（LINE・SNS）を「たくさん使う」機能</a:t>
+            </a:r>
+            <a:pPr indent="0" marL="0">
+              <a:buNone/>
+            </a:pPr>
+            <a:r>
+              <a:rPr lang="en-US" sz="1050" dirty="0">
+                <a:solidFill>
+                  <a:srgbClr val="5D667C"/>
+                </a:solidFill>
+                <a:latin typeface="Yu Gothic" pitchFamily="34" charset="0"/>
+                <a:ea typeface="Yu Gothic" pitchFamily="34" charset="-122"/>
+                <a:cs typeface="Yu Gothic" pitchFamily="34" charset="-120"/>
+              </a:rPr>
+              <a:t>　— AIは文章を作るたびにお金がかかる＝使うほど高い</a:t>
+            </a:r>
+            <a:endParaRPr lang="en-US" sz="1200" dirty="0"/>
+          </a:p>
+        </p:txBody>
+      </p:sp>
+      <p:sp>
+        <p:nvSpPr>
+          <p:cNvPr id="9" name="Text 7"/>
+          <p:cNvSpPr/>
+          <p:nvPr/>
+        </p:nvSpPr>
+        <p:spPr>
+          <a:xfrm>
+            <a:off x="457200" y="2395728"/>
+            <a:ext cx="9994392" cy="201168"/>
+          </a:xfrm>
+          <a:prstGeom prst="rect">
+            <a:avLst/>
+          </a:prstGeom>
+          <a:noFill/>
+          <a:ln/>
+        </p:spPr>
+        <p:txBody>
+          <a:bodyPr wrap="none" rtlCol="0" anchor="ctr"/>
+          <a:lstStyle/>
+          <a:p>
+            <a:pPr indent="0" marL="0">
+              <a:buNone/>
+            </a:pPr>
+            <a:r>
+              <a:rPr lang="en-US" sz="1050" dirty="0">
+                <a:solidFill>
+                  <a:srgbClr val="17223B"/>
+                </a:solidFill>
+                <a:latin typeface="Yu Gothic" pitchFamily="34" charset="0"/>
+                <a:ea typeface="Yu Gothic" pitchFamily="34" charset="-122"/>
+                <a:cs typeface="Yu Gothic" pitchFamily="34" charset="-120"/>
+              </a:rPr>
+              <a:t>⑤ LINE連携＋自動応答bot（LINE配信＋AI応答）</a:t>
+            </a:r>
+            <a:endParaRPr lang="en-US" sz="1050" dirty="0"/>
+          </a:p>
+        </p:txBody>
+      </p:sp>
+      <p:sp>
+        <p:nvSpPr>
+          <p:cNvPr id="10" name="Text 8"/>
+          <p:cNvSpPr/>
+          <p:nvPr/>
+        </p:nvSpPr>
+        <p:spPr>
+          <a:xfrm>
+            <a:off x="457200" y="2395728"/>
+            <a:ext cx="11274552" cy="201168"/>
+          </a:xfrm>
+          <a:prstGeom prst="rect">
+            <a:avLst/>
+          </a:prstGeom>
+          <a:noFill/>
+          <a:ln/>
+        </p:spPr>
+        <p:txBody>
+          <a:bodyPr wrap="square" rtlCol="0" anchor="ctr"/>
+          <a:lstStyle/>
+          <a:p>
+            <a:pPr algn="r" indent="0" marL="0">
+              <a:buNone/>
+            </a:pPr>
+            <a:r>
+              <a:rPr lang="en-US" sz="1200" b="1" dirty="0">
+                <a:solidFill>
+                  <a:srgbClr val="17223B"/>
+                </a:solidFill>
+                <a:latin typeface="Yu Gothic" pitchFamily="34" charset="0"/>
+                <a:ea typeface="Yu Gothic" pitchFamily="34" charset="-122"/>
+                <a:cs typeface="Yu Gothic" pitchFamily="34" charset="-120"/>
+              </a:rPr>
+              <a:t>15,000円</a:t>
+            </a:r>
+            <a:endParaRPr lang="en-US" sz="1200" dirty="0"/>
+          </a:p>
+        </p:txBody>
+      </p:sp>
+      <p:sp>
+        <p:nvSpPr>
+          <p:cNvPr id="11" name="Shape 9"/>
+          <p:cNvSpPr/>
+          <p:nvPr/>
+        </p:nvSpPr>
+        <p:spPr>
+          <a:xfrm>
+            <a:off x="457200" y="2615184"/>
+            <a:ext cx="11274552" cy="118872"/>
+          </a:xfrm>
+          <a:prstGeom prst="roundRect">
+            <a:avLst>
+              <a:gd name="adj" fmla="val 38462"/>
+            </a:avLst>
+          </a:prstGeom>
+          <a:solidFill>
+            <a:srgbClr val="EEEBE3"/>
+          </a:solidFill>
+          <a:ln w="9525">
+            <a:solidFill>
+              <a:srgbClr val="E4DFD3"/>
+            </a:solidFill>
+            <a:prstDash val="solid"/>
+          </a:ln>
+        </p:spPr>
+      </p:sp>
+      <p:sp>
+        <p:nvSpPr>
+          <p:cNvPr id="12" name="Shape 10"/>
+          <p:cNvSpPr/>
+          <p:nvPr/>
+        </p:nvSpPr>
+        <p:spPr>
+          <a:xfrm>
+            <a:off x="457200" y="2615184"/>
+            <a:ext cx="11274552" cy="118872"/>
+          </a:xfrm>
+          <a:prstGeom prst="roundRect">
+            <a:avLst>
+              <a:gd name="adj" fmla="val 38462"/>
+            </a:avLst>
+          </a:prstGeom>
+          <a:solidFill>
+            <a:srgbClr val="D9542F"/>
+          </a:solidFill>
+          <a:ln/>
+        </p:spPr>
+      </p:sp>
+      <p:sp>
+        <p:nvSpPr>
+          <p:cNvPr id="13" name="Text 11"/>
+          <p:cNvSpPr/>
+          <p:nvPr/>
+        </p:nvSpPr>
+        <p:spPr>
+          <a:xfrm>
+            <a:off x="457200" y="2798064"/>
+            <a:ext cx="9994392" cy="201168"/>
+          </a:xfrm>
+          <a:prstGeom prst="rect">
+            <a:avLst/>
+          </a:prstGeom>
+          <a:noFill/>
+          <a:ln/>
+        </p:spPr>
+        <p:txBody>
+          <a:bodyPr wrap="none" rtlCol="0" anchor="ctr"/>
+          <a:lstStyle/>
+          <a:p>
+            <a:pPr indent="0" marL="0">
+              <a:buNone/>
+            </a:pPr>
+            <a:r>
+              <a:rPr lang="en-US" sz="1050" dirty="0">
+                <a:solidFill>
+                  <a:srgbClr val="17223B"/>
+                </a:solidFill>
+                <a:latin typeface="Yu Gothic" pitchFamily="34" charset="0"/>
+                <a:ea typeface="Yu Gothic" pitchFamily="34" charset="-122"/>
+                <a:cs typeface="Yu Gothic" pitchFamily="34" charset="-120"/>
+              </a:rPr>
+              <a:t>⑥ AI提案書ジェネレーター（AIで文章作成）</a:t>
+            </a:r>
+            <a:endParaRPr lang="en-US" sz="1050" dirty="0"/>
+          </a:p>
+        </p:txBody>
+      </p:sp>
+      <p:sp>
+        <p:nvSpPr>
+          <p:cNvPr id="14" name="Text 12"/>
+          <p:cNvSpPr/>
+          <p:nvPr/>
+        </p:nvSpPr>
+        <p:spPr>
+          <a:xfrm>
+            <a:off x="457200" y="2798064"/>
+            <a:ext cx="11274552" cy="201168"/>
+          </a:xfrm>
+          <a:prstGeom prst="rect">
+            <a:avLst/>
+          </a:prstGeom>
+          <a:noFill/>
+          <a:ln/>
+        </p:spPr>
+        <p:txBody>
+          <a:bodyPr wrap="square" rtlCol="0" anchor="ctr"/>
+          <a:lstStyle/>
+          <a:p>
+            <a:pPr algn="r" indent="0" marL="0">
+              <a:buNone/>
+            </a:pPr>
+            <a:r>
+              <a:rPr lang="en-US" sz="1200" b="1" dirty="0">
+                <a:solidFill>
+                  <a:srgbClr val="17223B"/>
+                </a:solidFill>
+                <a:latin typeface="Yu Gothic" pitchFamily="34" charset="0"/>
+                <a:ea typeface="Yu Gothic" pitchFamily="34" charset="-122"/>
+                <a:cs typeface="Yu Gothic" pitchFamily="34" charset="-120"/>
+              </a:rPr>
+              <a:t>8,000円</a:t>
+            </a:r>
+            <a:endParaRPr lang="en-US" sz="1200" dirty="0"/>
+          </a:p>
+        </p:txBody>
+      </p:sp>
+      <p:sp>
+        <p:nvSpPr>
+          <p:cNvPr id="15" name="Shape 13"/>
+          <p:cNvSpPr/>
+          <p:nvPr/>
+        </p:nvSpPr>
+        <p:spPr>
+          <a:xfrm>
+            <a:off x="457200" y="3017520"/>
+            <a:ext cx="11274552" cy="118872"/>
+          </a:xfrm>
+          <a:prstGeom prst="roundRect">
+            <a:avLst>
+              <a:gd name="adj" fmla="val 38462"/>
+            </a:avLst>
+          </a:prstGeom>
+          <a:solidFill>
+            <a:srgbClr val="EEEBE3"/>
+          </a:solidFill>
+          <a:ln w="9525">
+            <a:solidFill>
+              <a:srgbClr val="E4DFD3"/>
+            </a:solidFill>
+            <a:prstDash val="solid"/>
+          </a:ln>
+        </p:spPr>
+      </p:sp>
+      <p:sp>
+        <p:nvSpPr>
+          <p:cNvPr id="16" name="Shape 14"/>
+          <p:cNvSpPr/>
+          <p:nvPr/>
+        </p:nvSpPr>
+        <p:spPr>
+          <a:xfrm>
+            <a:off x="457200" y="3017520"/>
+            <a:ext cx="5975513" cy="118872"/>
+          </a:xfrm>
+          <a:prstGeom prst="roundRect">
+            <a:avLst>
+              <a:gd name="adj" fmla="val 38462"/>
+            </a:avLst>
+          </a:prstGeom>
+          <a:solidFill>
+            <a:srgbClr val="D9542F"/>
+          </a:solidFill>
+          <a:ln/>
+        </p:spPr>
+      </p:sp>
+      <p:sp>
+        <p:nvSpPr>
+          <p:cNvPr id="17" name="Text 15"/>
+          <p:cNvSpPr/>
+          <p:nvPr/>
+        </p:nvSpPr>
+        <p:spPr>
+          <a:xfrm>
+            <a:off x="457200" y="3200400"/>
+            <a:ext cx="9994392" cy="201168"/>
+          </a:xfrm>
+          <a:prstGeom prst="rect">
+            <a:avLst/>
+          </a:prstGeom>
+          <a:noFill/>
+          <a:ln/>
+        </p:spPr>
+        <p:txBody>
+          <a:bodyPr wrap="none" rtlCol="0" anchor="ctr"/>
+          <a:lstStyle/>
+          <a:p>
+            <a:pPr indent="0" marL="0">
+              <a:buNone/>
+            </a:pPr>
+            <a:r>
+              <a:rPr lang="en-US" sz="1050" dirty="0">
+                <a:solidFill>
+                  <a:srgbClr val="17223B"/>
+                </a:solidFill>
+                <a:latin typeface="Yu Gothic" pitchFamily="34" charset="0"/>
+                <a:ea typeface="Yu Gothic" pitchFamily="34" charset="-122"/>
+                <a:cs typeface="Yu Gothic" pitchFamily="34" charset="-120"/>
+              </a:rPr>
+              <a:t>⑩ SNS影響力の自動集計（SNSのデータ取得）</a:t>
+            </a:r>
+            <a:endParaRPr lang="en-US" sz="1050" dirty="0"/>
+          </a:p>
+        </p:txBody>
+      </p:sp>
+      <p:sp>
+        <p:nvSpPr>
+          <p:cNvPr id="18" name="Text 16"/>
+          <p:cNvSpPr/>
+          <p:nvPr/>
+        </p:nvSpPr>
+        <p:spPr>
+          <a:xfrm>
+            <a:off x="457200" y="3200400"/>
+            <a:ext cx="11274552" cy="201168"/>
+          </a:xfrm>
+          <a:prstGeom prst="rect">
+            <a:avLst/>
+          </a:prstGeom>
+          <a:noFill/>
+          <a:ln/>
+        </p:spPr>
+        <p:txBody>
+          <a:bodyPr wrap="square" rtlCol="0" anchor="ctr"/>
+          <a:lstStyle/>
+          <a:p>
+            <a:pPr algn="r" indent="0" marL="0">
+              <a:buNone/>
+            </a:pPr>
+            <a:r>
+              <a:rPr lang="en-US" sz="1200" b="1" dirty="0">
+                <a:solidFill>
+                  <a:srgbClr val="17223B"/>
+                </a:solidFill>
+                <a:latin typeface="Yu Gothic" pitchFamily="34" charset="0"/>
+                <a:ea typeface="Yu Gothic" pitchFamily="34" charset="-122"/>
+                <a:cs typeface="Yu Gothic" pitchFamily="34" charset="-120"/>
+              </a:rPr>
+              <a:t>8,000円</a:t>
+            </a:r>
+            <a:endParaRPr lang="en-US" sz="1200" dirty="0"/>
+          </a:p>
+        </p:txBody>
+      </p:sp>
+      <p:sp>
+        <p:nvSpPr>
+          <p:cNvPr id="19" name="Shape 17"/>
+          <p:cNvSpPr/>
+          <p:nvPr/>
+        </p:nvSpPr>
+        <p:spPr>
+          <a:xfrm>
+            <a:off x="457200" y="3419856"/>
+            <a:ext cx="11274552" cy="118872"/>
+          </a:xfrm>
+          <a:prstGeom prst="roundRect">
+            <a:avLst>
+              <a:gd name="adj" fmla="val 38462"/>
+            </a:avLst>
+          </a:prstGeom>
+          <a:solidFill>
+            <a:srgbClr val="EEEBE3"/>
+          </a:solidFill>
+          <a:ln w="9525">
+            <a:solidFill>
+              <a:srgbClr val="E4DFD3"/>
+            </a:solidFill>
+            <a:prstDash val="solid"/>
+          </a:ln>
+        </p:spPr>
+      </p:sp>
+      <p:sp>
+        <p:nvSpPr>
+          <p:cNvPr id="20" name="Shape 18"/>
+          <p:cNvSpPr/>
+          <p:nvPr/>
+        </p:nvSpPr>
+        <p:spPr>
+          <a:xfrm>
+            <a:off x="457200" y="3419856"/>
+            <a:ext cx="5975513" cy="118872"/>
+          </a:xfrm>
+          <a:prstGeom prst="roundRect">
+            <a:avLst>
+              <a:gd name="adj" fmla="val 38462"/>
+            </a:avLst>
+          </a:prstGeom>
+          <a:solidFill>
+            <a:srgbClr val="D9542F"/>
+          </a:solidFill>
+          <a:ln/>
+        </p:spPr>
+      </p:sp>
+      <p:sp>
+        <p:nvSpPr>
+          <p:cNvPr id="21" name="Shape 19"/>
+          <p:cNvSpPr/>
+          <p:nvPr/>
+        </p:nvSpPr>
+        <p:spPr>
+          <a:xfrm>
+            <a:off x="457200" y="3675888"/>
+            <a:ext cx="155448" cy="155448"/>
+          </a:xfrm>
+          <a:prstGeom prst="roundRect">
+            <a:avLst>
+              <a:gd name="adj" fmla="val 23529"/>
+            </a:avLst>
+          </a:prstGeom>
+          <a:solidFill>
+            <a:srgbClr val="1667B5"/>
+          </a:solidFill>
+          <a:ln/>
+        </p:spPr>
+      </p:sp>
+      <p:sp>
+        <p:nvSpPr>
+          <p:cNvPr id="22" name="Text 20"/>
+          <p:cNvSpPr/>
+          <p:nvPr/>
+        </p:nvSpPr>
+        <p:spPr>
+          <a:xfrm>
+            <a:off x="713232" y="3621024"/>
+            <a:ext cx="11018520" cy="274320"/>
+          </a:xfrm>
+          <a:prstGeom prst="rect">
+            <a:avLst/>
+          </a:prstGeom>
+          <a:noFill/>
+          <a:ln/>
+        </p:spPr>
+        <p:txBody>
+          <a:bodyPr wrap="square" rtlCol="0" anchor="ctr"/>
+          <a:lstStyle/>
+          <a:p>
+            <a:pPr indent="0" marL="0">
+              <a:buNone/>
+            </a:pPr>
+            <a:r>
+              <a:rPr lang="en-US" sz="1200" b="1" dirty="0">
+                <a:solidFill>
+                  <a:srgbClr val="17223B"/>
+                </a:solidFill>
+                <a:latin typeface="Yu Gothic" pitchFamily="34" charset="0"/>
+                <a:ea typeface="Yu Gothic" pitchFamily="34" charset="-122"/>
+                <a:cs typeface="Yu Gothic" pitchFamily="34" charset="-120"/>
+              </a:rPr>
+              <a:t>ふつう：データをたくさん「保管」したり、AIを「少し」使う機能</a:t>
+            </a:r>
+            <a:pPr indent="0" marL="0">
+              <a:buNone/>
+            </a:pPr>
+            <a:endParaRPr lang="en-US" sz="1200" dirty="0"/>
+          </a:p>
+        </p:txBody>
+      </p:sp>
+      <p:sp>
+        <p:nvSpPr>
+          <p:cNvPr id="23" name="Text 21"/>
+          <p:cNvSpPr/>
+          <p:nvPr/>
+        </p:nvSpPr>
+        <p:spPr>
+          <a:xfrm>
+            <a:off x="457200" y="3959352"/>
+            <a:ext cx="9994392" cy="201168"/>
+          </a:xfrm>
+          <a:prstGeom prst="rect">
+            <a:avLst/>
+          </a:prstGeom>
+          <a:noFill/>
+          <a:ln/>
+        </p:spPr>
+        <p:txBody>
+          <a:bodyPr wrap="none" rtlCol="0" anchor="ctr"/>
+          <a:lstStyle/>
+          <a:p>
+            <a:pPr indent="0" marL="0">
+              <a:buNone/>
+            </a:pPr>
+            <a:r>
+              <a:rPr lang="en-US" sz="1050" dirty="0">
+                <a:solidFill>
+                  <a:srgbClr val="17223B"/>
+                </a:solidFill>
+                <a:latin typeface="Yu Gothic" pitchFamily="34" charset="0"/>
+                <a:ea typeface="Yu Gothic" pitchFamily="34" charset="-122"/>
+                <a:cs typeface="Yu Gothic" pitchFamily="34" charset="-120"/>
+              </a:rPr>
+              <a:t>① 統合データベース（全データの置き場）</a:t>
+            </a:r>
+            <a:endParaRPr lang="en-US" sz="1050" dirty="0"/>
+          </a:p>
+        </p:txBody>
+      </p:sp>
+      <p:sp>
+        <p:nvSpPr>
+          <p:cNvPr id="24" name="Text 22"/>
+          <p:cNvSpPr/>
+          <p:nvPr/>
+        </p:nvSpPr>
+        <p:spPr>
+          <a:xfrm>
+            <a:off x="457200" y="3959352"/>
+            <a:ext cx="11274552" cy="201168"/>
+          </a:xfrm>
+          <a:prstGeom prst="rect">
+            <a:avLst/>
+          </a:prstGeom>
+          <a:noFill/>
+          <a:ln/>
+        </p:spPr>
+        <p:txBody>
+          <a:bodyPr wrap="square" rtlCol="0" anchor="ctr"/>
+          <a:lstStyle/>
+          <a:p>
+            <a:pPr algn="r" indent="0" marL="0">
+              <a:buNone/>
+            </a:pPr>
+            <a:r>
+              <a:rPr lang="en-US" sz="1200" b="1" dirty="0">
+                <a:solidFill>
+                  <a:srgbClr val="17223B"/>
+                </a:solidFill>
+                <a:latin typeface="Yu Gothic" pitchFamily="34" charset="0"/>
+                <a:ea typeface="Yu Gothic" pitchFamily="34" charset="-122"/>
+                <a:cs typeface="Yu Gothic" pitchFamily="34" charset="-120"/>
+              </a:rPr>
+              <a:t>5,000円</a:t>
+            </a:r>
+            <a:endParaRPr lang="en-US" sz="1200" dirty="0"/>
+          </a:p>
+        </p:txBody>
+      </p:sp>
+      <p:sp>
+        <p:nvSpPr>
+          <p:cNvPr id="25" name="Shape 23"/>
+          <p:cNvSpPr/>
+          <p:nvPr/>
+        </p:nvSpPr>
+        <p:spPr>
+          <a:xfrm>
+            <a:off x="457200" y="4178808"/>
+            <a:ext cx="11274552" cy="118872"/>
+          </a:xfrm>
+          <a:prstGeom prst="roundRect">
+            <a:avLst>
+              <a:gd name="adj" fmla="val 38462"/>
+            </a:avLst>
+          </a:prstGeom>
+          <a:solidFill>
+            <a:srgbClr val="EEEBE3"/>
+          </a:solidFill>
+          <a:ln w="9525">
+            <a:solidFill>
+              <a:srgbClr val="E4DFD3"/>
+            </a:solidFill>
+            <a:prstDash val="solid"/>
+          </a:ln>
+        </p:spPr>
+      </p:sp>
+      <p:sp>
+        <p:nvSpPr>
+          <p:cNvPr id="26" name="Shape 24"/>
+          <p:cNvSpPr/>
+          <p:nvPr/>
+        </p:nvSpPr>
+        <p:spPr>
+          <a:xfrm>
+            <a:off x="457200" y="4178808"/>
+            <a:ext cx="3720602" cy="118872"/>
+          </a:xfrm>
+          <a:prstGeom prst="roundRect">
+            <a:avLst>
+              <a:gd name="adj" fmla="val 38462"/>
+            </a:avLst>
+          </a:prstGeom>
+          <a:solidFill>
+            <a:srgbClr val="1667B5"/>
+          </a:solidFill>
+          <a:ln/>
+        </p:spPr>
+      </p:sp>
+      <p:sp>
+        <p:nvSpPr>
+          <p:cNvPr id="27" name="Text 25"/>
+          <p:cNvSpPr/>
+          <p:nvPr/>
+        </p:nvSpPr>
+        <p:spPr>
+          <a:xfrm>
+            <a:off x="457200" y="4361688"/>
+            <a:ext cx="9994392" cy="201168"/>
+          </a:xfrm>
+          <a:prstGeom prst="rect">
+            <a:avLst/>
+          </a:prstGeom>
+          <a:noFill/>
+          <a:ln/>
+        </p:spPr>
+        <p:txBody>
+          <a:bodyPr wrap="none" rtlCol="0" anchor="ctr"/>
+          <a:lstStyle/>
+          <a:p>
+            <a:pPr indent="0" marL="0">
+              <a:buNone/>
+            </a:pPr>
+            <a:r>
+              <a:rPr lang="en-US" sz="1050" dirty="0">
+                <a:solidFill>
+                  <a:srgbClr val="17223B"/>
+                </a:solidFill>
+                <a:latin typeface="Yu Gothic" pitchFamily="34" charset="0"/>
+                <a:ea typeface="Yu Gothic" pitchFamily="34" charset="-122"/>
+                <a:cs typeface="Yu Gothic" pitchFamily="34" charset="-120"/>
+              </a:rPr>
+              <a:t>⑦ 実績ボード（AI報告文＋常時表示）</a:t>
+            </a:r>
+            <a:endParaRPr lang="en-US" sz="1050" dirty="0"/>
+          </a:p>
+        </p:txBody>
+      </p:sp>
+      <p:sp>
+        <p:nvSpPr>
+          <p:cNvPr id="28" name="Text 26"/>
+          <p:cNvSpPr/>
+          <p:nvPr/>
+        </p:nvSpPr>
+        <p:spPr>
+          <a:xfrm>
+            <a:off x="457200" y="4361688"/>
+            <a:ext cx="11274552" cy="201168"/>
+          </a:xfrm>
+          <a:prstGeom prst="rect">
+            <a:avLst/>
+          </a:prstGeom>
+          <a:noFill/>
+          <a:ln/>
+        </p:spPr>
+        <p:txBody>
+          <a:bodyPr wrap="square" rtlCol="0" anchor="ctr"/>
+          <a:lstStyle/>
+          <a:p>
+            <a:pPr algn="r" indent="0" marL="0">
+              <a:buNone/>
+            </a:pPr>
+            <a:r>
+              <a:rPr lang="en-US" sz="1200" b="1" dirty="0">
+                <a:solidFill>
+                  <a:srgbClr val="17223B"/>
+                </a:solidFill>
+                <a:latin typeface="Yu Gothic" pitchFamily="34" charset="0"/>
+                <a:ea typeface="Yu Gothic" pitchFamily="34" charset="-122"/>
+                <a:cs typeface="Yu Gothic" pitchFamily="34" charset="-120"/>
+              </a:rPr>
+              <a:t>5,000円</a:t>
+            </a:r>
+            <a:endParaRPr lang="en-US" sz="1200" dirty="0"/>
+          </a:p>
+        </p:txBody>
+      </p:sp>
+      <p:sp>
+        <p:nvSpPr>
+          <p:cNvPr id="29" name="Shape 27"/>
+          <p:cNvSpPr/>
+          <p:nvPr/>
+        </p:nvSpPr>
+        <p:spPr>
+          <a:xfrm>
+            <a:off x="457200" y="4581144"/>
+            <a:ext cx="11274552" cy="118872"/>
+          </a:xfrm>
+          <a:prstGeom prst="roundRect">
+            <a:avLst>
+              <a:gd name="adj" fmla="val 38462"/>
+            </a:avLst>
+          </a:prstGeom>
+          <a:solidFill>
+            <a:srgbClr val="EEEBE3"/>
+          </a:solidFill>
+          <a:ln w="9525">
+            <a:solidFill>
+              <a:srgbClr val="E4DFD3"/>
+            </a:solidFill>
+            <a:prstDash val="solid"/>
+          </a:ln>
+        </p:spPr>
+      </p:sp>
+      <p:sp>
+        <p:nvSpPr>
+          <p:cNvPr id="30" name="Shape 28"/>
+          <p:cNvSpPr/>
+          <p:nvPr/>
+        </p:nvSpPr>
+        <p:spPr>
+          <a:xfrm>
+            <a:off x="457200" y="4581144"/>
+            <a:ext cx="3720602" cy="118872"/>
+          </a:xfrm>
+          <a:prstGeom prst="roundRect">
+            <a:avLst>
+              <a:gd name="adj" fmla="val 38462"/>
+            </a:avLst>
+          </a:prstGeom>
+          <a:solidFill>
+            <a:srgbClr val="1667B5"/>
+          </a:solidFill>
+          <a:ln/>
+        </p:spPr>
+      </p:sp>
+      <p:sp>
+        <p:nvSpPr>
+          <p:cNvPr id="31" name="Text 29"/>
+          <p:cNvSpPr/>
+          <p:nvPr/>
+        </p:nvSpPr>
+        <p:spPr>
+          <a:xfrm>
+            <a:off x="457200" y="4764024"/>
+            <a:ext cx="9994392" cy="201168"/>
+          </a:xfrm>
+          <a:prstGeom prst="rect">
+            <a:avLst/>
+          </a:prstGeom>
+          <a:noFill/>
+          <a:ln/>
+        </p:spPr>
+        <p:txBody>
+          <a:bodyPr wrap="none" rtlCol="0" anchor="ctr"/>
+          <a:lstStyle/>
+          <a:p>
+            <a:pPr indent="0" marL="0">
+              <a:buNone/>
+            </a:pPr>
+            <a:r>
+              <a:rPr lang="en-US" sz="1050" dirty="0">
+                <a:solidFill>
+                  <a:srgbClr val="17223B"/>
+                </a:solidFill>
+                <a:latin typeface="Yu Gothic" pitchFamily="34" charset="0"/>
+                <a:ea typeface="Yu Gothic" pitchFamily="34" charset="-122"/>
+                <a:cs typeface="Yu Gothic" pitchFamily="34" charset="-120"/>
+              </a:rPr>
+              <a:t>⑧ 営業メール支援（AIで下書き）</a:t>
+            </a:r>
+            <a:endParaRPr lang="en-US" sz="1050" dirty="0"/>
+          </a:p>
+        </p:txBody>
+      </p:sp>
+      <p:sp>
+        <p:nvSpPr>
+          <p:cNvPr id="32" name="Text 30"/>
+          <p:cNvSpPr/>
+          <p:nvPr/>
+        </p:nvSpPr>
+        <p:spPr>
+          <a:xfrm>
+            <a:off x="457200" y="4764024"/>
+            <a:ext cx="11274552" cy="201168"/>
+          </a:xfrm>
+          <a:prstGeom prst="rect">
+            <a:avLst/>
+          </a:prstGeom>
+          <a:noFill/>
+          <a:ln/>
+        </p:spPr>
+        <p:txBody>
+          <a:bodyPr wrap="square" rtlCol="0" anchor="ctr"/>
+          <a:lstStyle/>
+          <a:p>
+            <a:pPr algn="r" indent="0" marL="0">
+              <a:buNone/>
+            </a:pPr>
+            <a:r>
+              <a:rPr lang="en-US" sz="1200" b="1" dirty="0">
+                <a:solidFill>
+                  <a:srgbClr val="17223B"/>
+                </a:solidFill>
+                <a:latin typeface="Yu Gothic" pitchFamily="34" charset="0"/>
+                <a:ea typeface="Yu Gothic" pitchFamily="34" charset="-122"/>
+                <a:cs typeface="Yu Gothic" pitchFamily="34" charset="-120"/>
+              </a:rPr>
+              <a:t>5,000円</a:t>
+            </a:r>
+            <a:endParaRPr lang="en-US" sz="1200" dirty="0"/>
+          </a:p>
+        </p:txBody>
+      </p:sp>
+      <p:sp>
+        <p:nvSpPr>
+          <p:cNvPr id="33" name="Shape 31"/>
+          <p:cNvSpPr/>
+          <p:nvPr/>
+        </p:nvSpPr>
+        <p:spPr>
+          <a:xfrm>
+            <a:off x="457200" y="4983480"/>
+            <a:ext cx="11274552" cy="118872"/>
+          </a:xfrm>
+          <a:prstGeom prst="roundRect">
+            <a:avLst>
+              <a:gd name="adj" fmla="val 38462"/>
+            </a:avLst>
+          </a:prstGeom>
+          <a:solidFill>
+            <a:srgbClr val="EEEBE3"/>
+          </a:solidFill>
+          <a:ln w="9525">
+            <a:solidFill>
+              <a:srgbClr val="E4DFD3"/>
+            </a:solidFill>
+            <a:prstDash val="solid"/>
+          </a:ln>
+        </p:spPr>
+      </p:sp>
+      <p:sp>
+        <p:nvSpPr>
+          <p:cNvPr id="34" name="Shape 32"/>
+          <p:cNvSpPr/>
+          <p:nvPr/>
+        </p:nvSpPr>
+        <p:spPr>
+          <a:xfrm>
+            <a:off x="457200" y="4983480"/>
+            <a:ext cx="3720602" cy="118872"/>
+          </a:xfrm>
+          <a:prstGeom prst="roundRect">
+            <a:avLst>
+              <a:gd name="adj" fmla="val 38462"/>
+            </a:avLst>
+          </a:prstGeom>
+          <a:solidFill>
+            <a:srgbClr val="1667B5"/>
+          </a:solidFill>
+          <a:ln/>
+        </p:spPr>
+      </p:sp>
+      <p:sp>
+        <p:nvSpPr>
+          <p:cNvPr id="35" name="Shape 33"/>
+          <p:cNvSpPr/>
+          <p:nvPr/>
+        </p:nvSpPr>
+        <p:spPr>
+          <a:xfrm>
+            <a:off x="457200" y="5239512"/>
+            <a:ext cx="155448" cy="155448"/>
+          </a:xfrm>
+          <a:prstGeom prst="roundRect">
+            <a:avLst>
+              <a:gd name="adj" fmla="val 23529"/>
+            </a:avLst>
+          </a:prstGeom>
+          <a:solidFill>
+            <a:srgbClr val="2E8B57"/>
+          </a:solidFill>
+          <a:ln/>
+        </p:spPr>
+      </p:sp>
+      <p:sp>
+        <p:nvSpPr>
+          <p:cNvPr id="36" name="Text 34"/>
+          <p:cNvSpPr/>
+          <p:nvPr/>
+        </p:nvSpPr>
+        <p:spPr>
+          <a:xfrm>
+            <a:off x="713232" y="5184648"/>
+            <a:ext cx="11018520" cy="274320"/>
+          </a:xfrm>
+          <a:prstGeom prst="rect">
+            <a:avLst/>
+          </a:prstGeom>
+          <a:noFill/>
+          <a:ln/>
+        </p:spPr>
+        <p:txBody>
+          <a:bodyPr wrap="square" rtlCol="0" anchor="ctr"/>
+          <a:lstStyle/>
+          <a:p>
+            <a:pPr indent="0" marL="0">
+              <a:buNone/>
+            </a:pPr>
+            <a:r>
+              <a:rPr lang="en-US" sz="1200" b="1" dirty="0">
+                <a:solidFill>
+                  <a:srgbClr val="17223B"/>
+                </a:solidFill>
+                <a:latin typeface="Yu Gothic" pitchFamily="34" charset="0"/>
+                <a:ea typeface="Yu Gothic" pitchFamily="34" charset="-122"/>
+                <a:cs typeface="Yu Gothic" pitchFamily="34" charset="-120"/>
+              </a:rPr>
+              <a:t>安い：おもに「保存・表示・通知」するだけの機能</a:t>
+            </a:r>
+            <a:pPr indent="0" marL="0">
+              <a:buNone/>
+            </a:pPr>
+            <a:r>
+              <a:rPr lang="en-US" sz="1050" dirty="0">
+                <a:solidFill>
+                  <a:srgbClr val="5D667C"/>
+                </a:solidFill>
+                <a:latin typeface="Yu Gothic" pitchFamily="34" charset="0"/>
+                <a:ea typeface="Yu Gothic" pitchFamily="34" charset="-122"/>
+                <a:cs typeface="Yu Gothic" pitchFamily="34" charset="-120"/>
+              </a:rPr>
+              <a:t>　— 電気代くらい</a:t>
+            </a:r>
+            <a:endParaRPr lang="en-US" sz="1200" dirty="0"/>
+          </a:p>
+        </p:txBody>
+      </p:sp>
+      <p:sp>
+        <p:nvSpPr>
+          <p:cNvPr id="37" name="Text 35"/>
+          <p:cNvSpPr/>
+          <p:nvPr/>
+        </p:nvSpPr>
+        <p:spPr>
+          <a:xfrm>
+            <a:off x="457200" y="5522976"/>
+            <a:ext cx="9994392" cy="201168"/>
+          </a:xfrm>
+          <a:prstGeom prst="rect">
+            <a:avLst/>
+          </a:prstGeom>
+          <a:noFill/>
+          <a:ln/>
+        </p:spPr>
+        <p:txBody>
+          <a:bodyPr wrap="none" rtlCol="0" anchor="ctr"/>
+          <a:lstStyle/>
+          <a:p>
+            <a:pPr indent="0" marL="0">
+              <a:buNone/>
+            </a:pPr>
+            <a:r>
+              <a:rPr lang="en-US" sz="1050" dirty="0">
+                <a:solidFill>
+                  <a:srgbClr val="17223B"/>
+                </a:solidFill>
+                <a:latin typeface="Yu Gothic" pitchFamily="34" charset="0"/>
+                <a:ea typeface="Yu Gothic" pitchFamily="34" charset="-122"/>
+                <a:cs typeface="Yu Gothic" pitchFamily="34" charset="-120"/>
+              </a:rPr>
+              <a:t>3,000円の7機能：②営業パイプライン・③スマホ音声タスク・④ダッシュボード・⑨契約更新・⑪ROIレポート・⑬少額集金・⑮選手ポータル</a:t>
+            </a:r>
+            <a:endParaRPr lang="en-US" sz="1050" dirty="0"/>
+          </a:p>
+        </p:txBody>
+      </p:sp>
+      <p:sp>
+        <p:nvSpPr>
+          <p:cNvPr id="38" name="Text 36"/>
+          <p:cNvSpPr/>
+          <p:nvPr/>
+        </p:nvSpPr>
+        <p:spPr>
+          <a:xfrm>
+            <a:off x="457200" y="5522976"/>
+            <a:ext cx="11274552" cy="201168"/>
+          </a:xfrm>
+          <a:prstGeom prst="rect">
+            <a:avLst/>
+          </a:prstGeom>
+          <a:noFill/>
+          <a:ln/>
+        </p:spPr>
+        <p:txBody>
+          <a:bodyPr wrap="square" rtlCol="0" anchor="ctr"/>
+          <a:lstStyle/>
+          <a:p>
+            <a:pPr algn="r" indent="0" marL="0">
+              <a:buNone/>
+            </a:pPr>
+            <a:r>
+              <a:rPr lang="en-US" sz="1200" b="1" dirty="0">
+                <a:solidFill>
+                  <a:srgbClr val="17223B"/>
+                </a:solidFill>
+                <a:latin typeface="Yu Gothic" pitchFamily="34" charset="0"/>
+                <a:ea typeface="Yu Gothic" pitchFamily="34" charset="-122"/>
+                <a:cs typeface="Yu Gothic" pitchFamily="34" charset="-120"/>
+              </a:rPr>
+              <a:t>3,000円</a:t>
+            </a:r>
+            <a:endParaRPr lang="en-US" sz="1200" dirty="0"/>
+          </a:p>
+        </p:txBody>
+      </p:sp>
+      <p:sp>
+        <p:nvSpPr>
+          <p:cNvPr id="39" name="Shape 37"/>
+          <p:cNvSpPr/>
+          <p:nvPr/>
+        </p:nvSpPr>
+        <p:spPr>
+          <a:xfrm>
+            <a:off x="457200" y="5742432"/>
+            <a:ext cx="11274552" cy="118872"/>
+          </a:xfrm>
+          <a:prstGeom prst="roundRect">
+            <a:avLst>
+              <a:gd name="adj" fmla="val 38462"/>
+            </a:avLst>
+          </a:prstGeom>
+          <a:solidFill>
+            <a:srgbClr val="EEEBE3"/>
+          </a:solidFill>
+          <a:ln w="9525">
+            <a:solidFill>
+              <a:srgbClr val="E4DFD3"/>
+            </a:solidFill>
+            <a:prstDash val="solid"/>
+          </a:ln>
+        </p:spPr>
+      </p:sp>
+      <p:sp>
+        <p:nvSpPr>
+          <p:cNvPr id="40" name="Shape 38"/>
+          <p:cNvSpPr/>
+          <p:nvPr/>
+        </p:nvSpPr>
+        <p:spPr>
+          <a:xfrm>
+            <a:off x="457200" y="5742432"/>
+            <a:ext cx="2254910" cy="118872"/>
+          </a:xfrm>
+          <a:prstGeom prst="roundRect">
+            <a:avLst>
+              <a:gd name="adj" fmla="val 38462"/>
+            </a:avLst>
+          </a:prstGeom>
+          <a:solidFill>
+            <a:srgbClr val="2E8B57"/>
+          </a:solidFill>
+          <a:ln/>
+        </p:spPr>
+      </p:sp>
+      <p:sp>
+        <p:nvSpPr>
+          <p:cNvPr id="41" name="Text 39"/>
+          <p:cNvSpPr/>
+          <p:nvPr/>
+        </p:nvSpPr>
+        <p:spPr>
+          <a:xfrm>
+            <a:off x="457200" y="5925312"/>
+            <a:ext cx="9994392" cy="201168"/>
+          </a:xfrm>
+          <a:prstGeom prst="rect">
+            <a:avLst/>
+          </a:prstGeom>
+          <a:noFill/>
+          <a:ln/>
+        </p:spPr>
+        <p:txBody>
+          <a:bodyPr wrap="none" rtlCol="0" anchor="ctr"/>
+          <a:lstStyle/>
+          <a:p>
+            <a:pPr indent="0" marL="0">
+              <a:buNone/>
+            </a:pPr>
+            <a:r>
+              <a:rPr lang="en-US" sz="1050" dirty="0">
+                <a:solidFill>
+                  <a:srgbClr val="17223B"/>
+                </a:solidFill>
+                <a:latin typeface="Yu Gothic" pitchFamily="34" charset="0"/>
+                <a:ea typeface="Yu Gothic" pitchFamily="34" charset="-122"/>
+                <a:cs typeface="Yu Gothic" pitchFamily="34" charset="-120"/>
+              </a:rPr>
+              <a:t>2,000円の4機能：⑫紹介管理・⑭特典配信・⑯カレンダー連携・⑰メディア連動</a:t>
+            </a:r>
+            <a:endParaRPr lang="en-US" sz="1050" dirty="0"/>
+          </a:p>
+        </p:txBody>
+      </p:sp>
+      <p:sp>
+        <p:nvSpPr>
+          <p:cNvPr id="42" name="Text 40"/>
+          <p:cNvSpPr/>
+          <p:nvPr/>
+        </p:nvSpPr>
+        <p:spPr>
+          <a:xfrm>
+            <a:off x="457200" y="5925312"/>
+            <a:ext cx="11274552" cy="201168"/>
+          </a:xfrm>
+          <a:prstGeom prst="rect">
+            <a:avLst/>
+          </a:prstGeom>
+          <a:noFill/>
+          <a:ln/>
+        </p:spPr>
+        <p:txBody>
+          <a:bodyPr wrap="square" rtlCol="0" anchor="ctr"/>
+          <a:lstStyle/>
+          <a:p>
+            <a:pPr algn="r" indent="0" marL="0">
+              <a:buNone/>
+            </a:pPr>
+            <a:r>
+              <a:rPr lang="en-US" sz="1200" b="1" dirty="0">
+                <a:solidFill>
+                  <a:srgbClr val="17223B"/>
+                </a:solidFill>
+                <a:latin typeface="Yu Gothic" pitchFamily="34" charset="0"/>
+                <a:ea typeface="Yu Gothic" pitchFamily="34" charset="-122"/>
+                <a:cs typeface="Yu Gothic" pitchFamily="34" charset="-120"/>
+              </a:rPr>
+              <a:t>2,000円</a:t>
+            </a:r>
+            <a:endParaRPr lang="en-US" sz="1200" dirty="0"/>
+          </a:p>
+        </p:txBody>
+      </p:sp>
+      <p:sp>
+        <p:nvSpPr>
+          <p:cNvPr id="43" name="Shape 41"/>
+          <p:cNvSpPr/>
+          <p:nvPr/>
+        </p:nvSpPr>
+        <p:spPr>
+          <a:xfrm>
+            <a:off x="457200" y="6144768"/>
+            <a:ext cx="11274552" cy="118872"/>
+          </a:xfrm>
+          <a:prstGeom prst="roundRect">
+            <a:avLst>
+              <a:gd name="adj" fmla="val 38462"/>
+            </a:avLst>
+          </a:prstGeom>
+          <a:solidFill>
+            <a:srgbClr val="EEEBE3"/>
+          </a:solidFill>
+          <a:ln w="9525">
+            <a:solidFill>
+              <a:srgbClr val="E4DFD3"/>
+            </a:solidFill>
+            <a:prstDash val="solid"/>
+          </a:ln>
+        </p:spPr>
+      </p:sp>
+      <p:sp>
+        <p:nvSpPr>
+          <p:cNvPr id="44" name="Shape 42"/>
+          <p:cNvSpPr/>
+          <p:nvPr/>
+        </p:nvSpPr>
+        <p:spPr>
+          <a:xfrm>
+            <a:off x="457200" y="6144768"/>
+            <a:ext cx="1465692" cy="118872"/>
+          </a:xfrm>
+          <a:prstGeom prst="roundRect">
+            <a:avLst>
+              <a:gd name="adj" fmla="val 38462"/>
+            </a:avLst>
+          </a:prstGeom>
+          <a:solidFill>
+            <a:srgbClr val="2E8B57"/>
+          </a:solidFill>
+          <a:ln/>
+        </p:spPr>
+      </p:sp>
+      <p:sp>
+        <p:nvSpPr>
+          <p:cNvPr id="45" name="Shape 43"/>
+          <p:cNvSpPr/>
+          <p:nvPr/>
+        </p:nvSpPr>
+        <p:spPr>
+          <a:xfrm>
+            <a:off x="457200" y="6053328"/>
+            <a:ext cx="11274552" cy="603504"/>
+          </a:xfrm>
+          <a:prstGeom prst="roundRect">
+            <a:avLst>
+              <a:gd name="adj" fmla="val 12121"/>
             </a:avLst>
           </a:prstGeom>
           <a:solidFill>
@@ -2454,14 +3893,14 @@
       </p:sp>
       <p:sp>
         <p:nvSpPr>
-          <p:cNvPr id="6" name="Text 4"/>
-          <p:cNvSpPr/>
-          <p:nvPr/>
-        </p:nvSpPr>
-        <p:spPr>
-          <a:xfrm>
-            <a:off x="685800" y="2404872"/>
-            <a:ext cx="2052828" cy="320040"/>
+          <p:cNvPr id="46" name="Text 44"/>
+          <p:cNvSpPr/>
+          <p:nvPr/>
+        </p:nvSpPr>
+        <p:spPr>
+          <a:xfrm>
+            <a:off x="713232" y="6053328"/>
+            <a:ext cx="10817352" cy="603504"/>
           </a:xfrm>
           <a:prstGeom prst="rect">
             <a:avLst/>
@@ -2474,10 +3913,30 @@
           <a:lstStyle/>
           <a:p>
             <a:pPr indent="0" marL="0">
-              <a:buNone/>
-            </a:pPr>
-            <a:r>
-              <a:rPr lang="en-US" sz="1200" b="1" spc="50" kern="0" dirty="0">
+              <a:lnSpc>
+                <a:spcPct val="115000"/>
+              </a:lnSpc>
+              <a:buNone/>
+            </a:pPr>
+            <a:r>
+              <a:rPr lang="en-US" sz="1150" b="1" dirty="0">
+                <a:solidFill>
+                  <a:srgbClr val="17223B"/>
+                </a:solidFill>
+                <a:latin typeface="Yu Gothic" pitchFamily="34" charset="0"/>
+                <a:ea typeface="Yu Gothic" pitchFamily="34" charset="-122"/>
+                <a:cs typeface="Yu Gothic" pitchFamily="34" charset="-120"/>
+              </a:rPr>
+              <a:t>ぜんぶ足すと… </a:t>
+            </a:r>
+            <a:pPr indent="0" marL="0">
+              <a:lnSpc>
+                <a:spcPct val="115000"/>
+              </a:lnSpc>
+              <a:buNone/>
+            </a:pPr>
+            <a:r>
+              <a:rPr lang="en-US" sz="1150" dirty="0">
                 <a:solidFill>
                   <a:srgbClr val="5D667C"/>
                 </a:solidFill>
@@ -2485,41 +3944,16 @@
                 <a:ea typeface="Yu Gothic" pitchFamily="34" charset="-122"/>
                 <a:cs typeface="Yu Gothic" pitchFamily="34" charset="-120"/>
               </a:rPr>
-              <a:t>STEP 0</a:t>
-            </a:r>
-            <a:endParaRPr lang="en-US" sz="1200" dirty="0"/>
-          </a:p>
-        </p:txBody>
-      </p:sp>
-      <p:sp>
-        <p:nvSpPr>
-          <p:cNvPr id="7" name="Text 5"/>
-          <p:cNvSpPr/>
-          <p:nvPr/>
-        </p:nvSpPr>
-        <p:spPr>
-          <a:xfrm>
-            <a:off x="685800" y="2807208"/>
-            <a:ext cx="2052828" cy="640080"/>
-          </a:xfrm>
-          <a:prstGeom prst="rect">
-            <a:avLst/>
-          </a:prstGeom>
-          <a:noFill/>
-          <a:ln/>
-        </p:spPr>
-        <p:txBody>
-          <a:bodyPr wrap="square" rtlCol="0" anchor="t"/>
-          <a:lstStyle/>
-          <a:p>
+              <a:t>17機能の月額合計 ＝ </a:t>
+            </a:r>
             <a:pPr indent="0" marL="0">
               <a:lnSpc>
-                <a:spcPct val="105000"/>
+                <a:spcPct val="115000"/>
               </a:lnSpc>
               <a:buNone/>
             </a:pPr>
             <a:r>
-              <a:rPr lang="en-US" sz="1550" b="1" dirty="0">
+              <a:rPr lang="en-US" sz="1150" b="1" dirty="0">
                 <a:solidFill>
                   <a:srgbClr val="17223B"/>
                 </a:solidFill>
@@ -2527,36 +3961,11 @@
                 <a:ea typeface="Yu Gothic" pitchFamily="34" charset="-122"/>
                 <a:cs typeface="Yu Gothic" pitchFamily="34" charset="-120"/>
               </a:rPr>
-              <a:t>スモールスタート</a:t>
-            </a:r>
-            <a:endParaRPr lang="en-US" sz="1550" dirty="0"/>
-          </a:p>
-        </p:txBody>
-      </p:sp>
-      <p:sp>
-        <p:nvSpPr>
-          <p:cNvPr id="8" name="Text 6"/>
-          <p:cNvSpPr/>
-          <p:nvPr/>
-        </p:nvSpPr>
-        <p:spPr>
-          <a:xfrm>
-            <a:off x="685800" y="3566160"/>
-            <a:ext cx="2052828" cy="777240"/>
-          </a:xfrm>
-          <a:prstGeom prst="rect">
-            <a:avLst/>
-          </a:prstGeom>
-          <a:noFill/>
-          <a:ln/>
-        </p:spPr>
-        <p:txBody>
-          <a:bodyPr wrap="square" rtlCol="0" anchor="t"/>
-          <a:lstStyle/>
-          <a:p>
+              <a:t>約7.5万円/月</a:t>
+            </a:r>
             <a:pPr indent="0" marL="0">
               <a:lnSpc>
-                <a:spcPct val="120000"/>
+                <a:spcPct val="115000"/>
               </a:lnSpc>
               <a:buNone/>
             </a:pPr>
@@ -2569,701 +3978,77 @@
                 <a:ea typeface="Yu Gothic" pitchFamily="34" charset="-122"/>
                 <a:cs typeface="Yu Gothic" pitchFamily="34" charset="-120"/>
               </a:rPr>
-              <a:t>土台のみ・約100万＋月10万で走り始める。</a:t>
+              <a:t>（サービスの実費）　＋　KOKUの</a:t>
+            </a:r>
+            <a:pPr indent="0" marL="0">
+              <a:lnSpc>
+                <a:spcPct val="115000"/>
+              </a:lnSpc>
+              <a:buNone/>
+            </a:pPr>
+            <a:r>
+              <a:rPr lang="en-US" sz="1150" b="1" dirty="0">
+                <a:solidFill>
+                  <a:srgbClr val="17223B"/>
+                </a:solidFill>
+                <a:latin typeface="Yu Gothic" pitchFamily="34" charset="0"/>
+                <a:ea typeface="Yu Gothic" pitchFamily="34" charset="-122"/>
+                <a:cs typeface="Yu Gothic" pitchFamily="34" charset="-120"/>
+              </a:rPr>
+              <a:t>お守り代（保守）3〜6万円</a:t>
+            </a:r>
+            <a:pPr indent="0" marL="0">
+              <a:lnSpc>
+                <a:spcPct val="115000"/>
+              </a:lnSpc>
+              <a:buNone/>
+            </a:pPr>
+            <a:r>
+              <a:rPr lang="en-US" sz="1150" dirty="0">
+                <a:solidFill>
+                  <a:srgbClr val="5D667C"/>
+                </a:solidFill>
+                <a:latin typeface="Yu Gothic" pitchFamily="34" charset="0"/>
+                <a:ea typeface="Yu Gothic" pitchFamily="34" charset="-122"/>
+                <a:cs typeface="Yu Gothic" pitchFamily="34" charset="-120"/>
+              </a:rPr>
+              <a:t>　</a:t>
+            </a:r>
+            <a:pPr indent="0" marL="0">
+              <a:lnSpc>
+                <a:spcPct val="115000"/>
+              </a:lnSpc>
+              <a:buNone/>
+            </a:pPr>
+            <a:r>
+              <a:rPr lang="en-US" sz="1150" b="1" dirty="0">
+                <a:solidFill>
+                  <a:srgbClr val="B7431F"/>
+                </a:solidFill>
+                <a:latin typeface="Yu Gothic" pitchFamily="34" charset="0"/>
+                <a:ea typeface="Yu Gothic" pitchFamily="34" charset="-122"/>
+                <a:cs typeface="Yu Gothic" pitchFamily="34" charset="-120"/>
+              </a:rPr>
+              <a:t>＝ プラン月額 10〜20万円</a:t>
+            </a:r>
+            <a:pPr indent="0" marL="0">
+              <a:lnSpc>
+                <a:spcPct val="115000"/>
+              </a:lnSpc>
+              <a:buNone/>
+            </a:pPr>
+            <a:r>
+              <a:rPr lang="en-US" sz="950" dirty="0">
+                <a:solidFill>
+                  <a:srgbClr val="5D667C"/>
+                </a:solidFill>
+                <a:latin typeface="Yu Gothic" pitchFamily="34" charset="0"/>
+                <a:ea typeface="Yu Gothic" pitchFamily="34" charset="-122"/>
+                <a:cs typeface="Yu Gothic" pitchFamily="34" charset="-120"/>
+              </a:rPr>
+              <a:t>　※⑬集金は別途 決済手数料（取引額×約3.6%）</a:t>
             </a:r>
             <a:endParaRPr lang="en-US" sz="1150" dirty="0"/>
-          </a:p>
-        </p:txBody>
-      </p:sp>
-      <p:sp>
-        <p:nvSpPr>
-          <p:cNvPr id="9" name="Text 7"/>
-          <p:cNvSpPr/>
-          <p:nvPr/>
-        </p:nvSpPr>
-        <p:spPr>
-          <a:xfrm>
-            <a:off x="2948940" y="2148840"/>
-            <a:ext cx="411480" cy="2286000"/>
-          </a:xfrm>
-          <a:prstGeom prst="rect">
-            <a:avLst/>
-          </a:prstGeom>
-          <a:noFill/>
-          <a:ln/>
-        </p:spPr>
-        <p:txBody>
-          <a:bodyPr wrap="square" rtlCol="0" anchor="ctr"/>
-          <a:lstStyle/>
-          <a:p>
-            <a:pPr algn="ctr" indent="0" marL="0">
-              <a:buNone/>
-            </a:pPr>
-            <a:r>
-              <a:rPr lang="en-US" sz="2200" b="1" dirty="0">
-                <a:solidFill>
-                  <a:srgbClr val="D9542F"/>
-                </a:solidFill>
-                <a:latin typeface="Yu Gothic" pitchFamily="34" charset="0"/>
-                <a:ea typeface="Yu Gothic" pitchFamily="34" charset="-122"/>
-                <a:cs typeface="Yu Gothic" pitchFamily="34" charset="-120"/>
-              </a:rPr>
-              <a:t>→</a:t>
-            </a:r>
-            <a:endParaRPr lang="en-US" sz="2200" dirty="0"/>
-          </a:p>
-        </p:txBody>
-      </p:sp>
-      <p:sp>
-        <p:nvSpPr>
-          <p:cNvPr id="10" name="Shape 8"/>
-          <p:cNvSpPr/>
-          <p:nvPr/>
-        </p:nvSpPr>
-        <p:spPr>
-          <a:xfrm>
-            <a:off x="3378708" y="2148840"/>
-            <a:ext cx="2510028" cy="2286000"/>
-          </a:xfrm>
-          <a:prstGeom prst="roundRect">
-            <a:avLst>
-              <a:gd name="adj" fmla="val 4000"/>
-            </a:avLst>
-          </a:prstGeom>
-          <a:solidFill>
-            <a:srgbClr val="F7F5F0"/>
-          </a:solidFill>
-          <a:ln w="12700">
-            <a:solidFill>
-              <a:srgbClr val="E4DFD3"/>
-            </a:solidFill>
-            <a:prstDash val="solid"/>
-          </a:ln>
-        </p:spPr>
-      </p:sp>
-      <p:sp>
-        <p:nvSpPr>
-          <p:cNvPr id="11" name="Text 9"/>
-          <p:cNvSpPr/>
-          <p:nvPr/>
-        </p:nvSpPr>
-        <p:spPr>
-          <a:xfrm>
-            <a:off x="3607308" y="2404872"/>
-            <a:ext cx="2052828" cy="320040"/>
-          </a:xfrm>
-          <a:prstGeom prst="rect">
-            <a:avLst/>
-          </a:prstGeom>
-          <a:noFill/>
-          <a:ln/>
-        </p:spPr>
-        <p:txBody>
-          <a:bodyPr wrap="square" rtlCol="0" anchor="ctr"/>
-          <a:lstStyle/>
-          <a:p>
-            <a:pPr indent="0" marL="0">
-              <a:buNone/>
-            </a:pPr>
-            <a:r>
-              <a:rPr lang="en-US" sz="1200" b="1" spc="50" kern="0" dirty="0">
-                <a:solidFill>
-                  <a:srgbClr val="B7431F"/>
-                </a:solidFill>
-                <a:latin typeface="Yu Gothic" pitchFamily="34" charset="0"/>
-                <a:ea typeface="Yu Gothic" pitchFamily="34" charset="-122"/>
-                <a:cs typeface="Yu Gothic" pitchFamily="34" charset="-120"/>
-              </a:rPr>
-              <a:t>STEP 1 ★★★★★</a:t>
-            </a:r>
-            <a:endParaRPr lang="en-US" sz="1200" dirty="0"/>
-          </a:p>
-        </p:txBody>
-      </p:sp>
-      <p:sp>
-        <p:nvSpPr>
-          <p:cNvPr id="12" name="Text 10"/>
-          <p:cNvSpPr/>
-          <p:nvPr/>
-        </p:nvSpPr>
-        <p:spPr>
-          <a:xfrm>
-            <a:off x="3607308" y="2807208"/>
-            <a:ext cx="2052828" cy="640080"/>
-          </a:xfrm>
-          <a:prstGeom prst="rect">
-            <a:avLst/>
-          </a:prstGeom>
-          <a:noFill/>
-          <a:ln/>
-        </p:spPr>
-        <p:txBody>
-          <a:bodyPr wrap="square" rtlCol="0" anchor="t"/>
-          <a:lstStyle/>
-          <a:p>
-            <a:pPr indent="0" marL="0">
-              <a:lnSpc>
-                <a:spcPct val="105000"/>
-              </a:lnSpc>
-              <a:buNone/>
-            </a:pPr>
-            <a:r>
-              <a:rPr lang="en-US" sz="1550" b="1" dirty="0">
-                <a:solidFill>
-                  <a:srgbClr val="17223B"/>
-                </a:solidFill>
-                <a:latin typeface="Yu Gothic" pitchFamily="34" charset="0"/>
-                <a:ea typeface="Yu Gothic" pitchFamily="34" charset="-122"/>
-                <a:cs typeface="Yu Gothic" pitchFamily="34" charset="-120"/>
-              </a:rPr>
-              <a:t>⑨ 契約更新アラート</a:t>
-            </a:r>
-            <a:endParaRPr lang="en-US" sz="1550" dirty="0"/>
-          </a:p>
-        </p:txBody>
-      </p:sp>
-      <p:sp>
-        <p:nvSpPr>
-          <p:cNvPr id="13" name="Text 11"/>
-          <p:cNvSpPr/>
-          <p:nvPr/>
-        </p:nvSpPr>
-        <p:spPr>
-          <a:xfrm>
-            <a:off x="3607308" y="3566160"/>
-            <a:ext cx="2052828" cy="777240"/>
-          </a:xfrm>
-          <a:prstGeom prst="rect">
-            <a:avLst/>
-          </a:prstGeom>
-          <a:noFill/>
-          <a:ln/>
-        </p:spPr>
-        <p:txBody>
-          <a:bodyPr wrap="square" rtlCol="0" anchor="t"/>
-          <a:lstStyle/>
-          <a:p>
-            <a:pPr indent="0" marL="0">
-              <a:lnSpc>
-                <a:spcPct val="120000"/>
-              </a:lnSpc>
-              <a:buNone/>
-            </a:pPr>
-            <a:r>
-              <a:rPr lang="en-US" sz="1150" dirty="0">
-                <a:solidFill>
-                  <a:srgbClr val="5D667C"/>
-                </a:solidFill>
-                <a:latin typeface="Yu Gothic" pitchFamily="34" charset="0"/>
-                <a:ea typeface="Yu Gothic" pitchFamily="34" charset="-122"/>
-                <a:cs typeface="Yu Gothic" pitchFamily="34" charset="-120"/>
-              </a:rPr>
-              <a:t>うっかり失注を防ぎ、まず「守り」を固める。</a:t>
-            </a:r>
-            <a:endParaRPr lang="en-US" sz="1150" dirty="0"/>
-          </a:p>
-        </p:txBody>
-      </p:sp>
-      <p:sp>
-        <p:nvSpPr>
-          <p:cNvPr id="14" name="Text 12"/>
-          <p:cNvSpPr/>
-          <p:nvPr/>
-        </p:nvSpPr>
-        <p:spPr>
-          <a:xfrm>
-            <a:off x="5870448" y="2148840"/>
-            <a:ext cx="411480" cy="2286000"/>
-          </a:xfrm>
-          <a:prstGeom prst="rect">
-            <a:avLst/>
-          </a:prstGeom>
-          <a:noFill/>
-          <a:ln/>
-        </p:spPr>
-        <p:txBody>
-          <a:bodyPr wrap="square" rtlCol="0" anchor="ctr"/>
-          <a:lstStyle/>
-          <a:p>
-            <a:pPr algn="ctr" indent="0" marL="0">
-              <a:buNone/>
-            </a:pPr>
-            <a:r>
-              <a:rPr lang="en-US" sz="2200" b="1" dirty="0">
-                <a:solidFill>
-                  <a:srgbClr val="D9542F"/>
-                </a:solidFill>
-                <a:latin typeface="Yu Gothic" pitchFamily="34" charset="0"/>
-                <a:ea typeface="Yu Gothic" pitchFamily="34" charset="-122"/>
-                <a:cs typeface="Yu Gothic" pitchFamily="34" charset="-120"/>
-              </a:rPr>
-              <a:t>→</a:t>
-            </a:r>
-            <a:endParaRPr lang="en-US" sz="2200" dirty="0"/>
-          </a:p>
-        </p:txBody>
-      </p:sp>
-      <p:sp>
-        <p:nvSpPr>
-          <p:cNvPr id="15" name="Shape 13"/>
-          <p:cNvSpPr/>
-          <p:nvPr/>
-        </p:nvSpPr>
-        <p:spPr>
-          <a:xfrm>
-            <a:off x="6300216" y="2148840"/>
-            <a:ext cx="2510028" cy="2286000"/>
-          </a:xfrm>
-          <a:prstGeom prst="roundRect">
-            <a:avLst>
-              <a:gd name="adj" fmla="val 4000"/>
-            </a:avLst>
-          </a:prstGeom>
-          <a:solidFill>
-            <a:srgbClr val="F7F5F0"/>
-          </a:solidFill>
-          <a:ln w="12700">
-            <a:solidFill>
-              <a:srgbClr val="E4DFD3"/>
-            </a:solidFill>
-            <a:prstDash val="solid"/>
-          </a:ln>
-        </p:spPr>
-      </p:sp>
-      <p:sp>
-        <p:nvSpPr>
-          <p:cNvPr id="16" name="Text 14"/>
-          <p:cNvSpPr/>
-          <p:nvPr/>
-        </p:nvSpPr>
-        <p:spPr>
-          <a:xfrm>
-            <a:off x="6528816" y="2404872"/>
-            <a:ext cx="2052828" cy="320040"/>
-          </a:xfrm>
-          <a:prstGeom prst="rect">
-            <a:avLst/>
-          </a:prstGeom>
-          <a:noFill/>
-          <a:ln/>
-        </p:spPr>
-        <p:txBody>
-          <a:bodyPr wrap="square" rtlCol="0" anchor="ctr"/>
-          <a:lstStyle/>
-          <a:p>
-            <a:pPr indent="0" marL="0">
-              <a:buNone/>
-            </a:pPr>
-            <a:r>
-              <a:rPr lang="en-US" sz="1200" b="1" spc="50" kern="0" dirty="0">
-                <a:solidFill>
-                  <a:srgbClr val="CF9526"/>
-                </a:solidFill>
-                <a:latin typeface="Yu Gothic" pitchFamily="34" charset="0"/>
-                <a:ea typeface="Yu Gothic" pitchFamily="34" charset="-122"/>
-                <a:cs typeface="Yu Gothic" pitchFamily="34" charset="-120"/>
-              </a:rPr>
-              <a:t>STEP 2 ★★★★</a:t>
-            </a:r>
-            <a:endParaRPr lang="en-US" sz="1200" dirty="0"/>
-          </a:p>
-        </p:txBody>
-      </p:sp>
-      <p:sp>
-        <p:nvSpPr>
-          <p:cNvPr id="17" name="Text 15"/>
-          <p:cNvSpPr/>
-          <p:nvPr/>
-        </p:nvSpPr>
-        <p:spPr>
-          <a:xfrm>
-            <a:off x="6528816" y="2807208"/>
-            <a:ext cx="2052828" cy="640080"/>
-          </a:xfrm>
-          <a:prstGeom prst="rect">
-            <a:avLst/>
-          </a:prstGeom>
-          <a:noFill/>
-          <a:ln/>
-        </p:spPr>
-        <p:txBody>
-          <a:bodyPr wrap="square" rtlCol="0" anchor="t"/>
-          <a:lstStyle/>
-          <a:p>
-            <a:pPr indent="0" marL="0">
-              <a:lnSpc>
-                <a:spcPct val="105000"/>
-              </a:lnSpc>
-              <a:buNone/>
-            </a:pPr>
-            <a:r>
-              <a:rPr lang="en-US" sz="1550" b="1" dirty="0">
-                <a:solidFill>
-                  <a:srgbClr val="17223B"/>
-                </a:solidFill>
-                <a:latin typeface="Yu Gothic" pitchFamily="34" charset="0"/>
-                <a:ea typeface="Yu Gothic" pitchFamily="34" charset="-122"/>
-                <a:cs typeface="Yu Gothic" pitchFamily="34" charset="-120"/>
-              </a:rPr>
-              <a:t>⑪ ROI・露出レポート</a:t>
-            </a:r>
-            <a:endParaRPr lang="en-US" sz="1550" dirty="0"/>
-          </a:p>
-        </p:txBody>
-      </p:sp>
-      <p:sp>
-        <p:nvSpPr>
-          <p:cNvPr id="18" name="Text 16"/>
-          <p:cNvSpPr/>
-          <p:nvPr/>
-        </p:nvSpPr>
-        <p:spPr>
-          <a:xfrm>
-            <a:off x="6528816" y="3566160"/>
-            <a:ext cx="2052828" cy="777240"/>
-          </a:xfrm>
-          <a:prstGeom prst="rect">
-            <a:avLst/>
-          </a:prstGeom>
-          <a:noFill/>
-          <a:ln/>
-        </p:spPr>
-        <p:txBody>
-          <a:bodyPr wrap="square" rtlCol="0" anchor="t"/>
-          <a:lstStyle/>
-          <a:p>
-            <a:pPr indent="0" marL="0">
-              <a:lnSpc>
-                <a:spcPct val="120000"/>
-              </a:lnSpc>
-              <a:buNone/>
-            </a:pPr>
-            <a:r>
-              <a:rPr lang="en-US" sz="1150" dirty="0">
-                <a:solidFill>
-                  <a:srgbClr val="5D667C"/>
-                </a:solidFill>
-                <a:latin typeface="Yu Gothic" pitchFamily="34" charset="0"/>
-                <a:ea typeface="Yu Gothic" pitchFamily="34" charset="-122"/>
-                <a:cs typeface="Yu Gothic" pitchFamily="34" charset="-120"/>
-              </a:rPr>
-              <a:t>効果を見せて、継続（更新）の決め手に。</a:t>
-            </a:r>
-            <a:endParaRPr lang="en-US" sz="1150" dirty="0"/>
-          </a:p>
-        </p:txBody>
-      </p:sp>
-      <p:sp>
-        <p:nvSpPr>
-          <p:cNvPr id="19" name="Text 17"/>
-          <p:cNvSpPr/>
-          <p:nvPr/>
-        </p:nvSpPr>
-        <p:spPr>
-          <a:xfrm>
-            <a:off x="8791956" y="2148840"/>
-            <a:ext cx="411480" cy="2286000"/>
-          </a:xfrm>
-          <a:prstGeom prst="rect">
-            <a:avLst/>
-          </a:prstGeom>
-          <a:noFill/>
-          <a:ln/>
-        </p:spPr>
-        <p:txBody>
-          <a:bodyPr wrap="square" rtlCol="0" anchor="ctr"/>
-          <a:lstStyle/>
-          <a:p>
-            <a:pPr algn="ctr" indent="0" marL="0">
-              <a:buNone/>
-            </a:pPr>
-            <a:r>
-              <a:rPr lang="en-US" sz="2200" b="1" dirty="0">
-                <a:solidFill>
-                  <a:srgbClr val="D9542F"/>
-                </a:solidFill>
-                <a:latin typeface="Yu Gothic" pitchFamily="34" charset="0"/>
-                <a:ea typeface="Yu Gothic" pitchFamily="34" charset="-122"/>
-                <a:cs typeface="Yu Gothic" pitchFamily="34" charset="-120"/>
-              </a:rPr>
-              <a:t>→</a:t>
-            </a:r>
-            <a:endParaRPr lang="en-US" sz="2200" dirty="0"/>
-          </a:p>
-        </p:txBody>
-      </p:sp>
-      <p:sp>
-        <p:nvSpPr>
-          <p:cNvPr id="20" name="Shape 18"/>
-          <p:cNvSpPr/>
-          <p:nvPr/>
-        </p:nvSpPr>
-        <p:spPr>
-          <a:xfrm>
-            <a:off x="9221724" y="2148840"/>
-            <a:ext cx="2510028" cy="2286000"/>
-          </a:xfrm>
-          <a:prstGeom prst="roundRect">
-            <a:avLst>
-              <a:gd name="adj" fmla="val 4000"/>
-            </a:avLst>
-          </a:prstGeom>
-          <a:solidFill>
-            <a:srgbClr val="F7F5F0"/>
-          </a:solidFill>
-          <a:ln w="12700">
-            <a:solidFill>
-              <a:srgbClr val="E4DFD3"/>
-            </a:solidFill>
-            <a:prstDash val="solid"/>
-          </a:ln>
-        </p:spPr>
-      </p:sp>
-      <p:sp>
-        <p:nvSpPr>
-          <p:cNvPr id="21" name="Text 19"/>
-          <p:cNvSpPr/>
-          <p:nvPr/>
-        </p:nvSpPr>
-        <p:spPr>
-          <a:xfrm>
-            <a:off x="9450324" y="2404872"/>
-            <a:ext cx="2052828" cy="320040"/>
-          </a:xfrm>
-          <a:prstGeom prst="rect">
-            <a:avLst/>
-          </a:prstGeom>
-          <a:noFill/>
-          <a:ln/>
-        </p:spPr>
-        <p:txBody>
-          <a:bodyPr wrap="square" rtlCol="0" anchor="ctr"/>
-          <a:lstStyle/>
-          <a:p>
-            <a:pPr indent="0" marL="0">
-              <a:buNone/>
-            </a:pPr>
-            <a:r>
-              <a:rPr lang="en-US" sz="1200" b="1" spc="50" kern="0" dirty="0">
-                <a:solidFill>
-                  <a:srgbClr val="CF9526"/>
-                </a:solidFill>
-                <a:latin typeface="Yu Gothic" pitchFamily="34" charset="0"/>
-                <a:ea typeface="Yu Gothic" pitchFamily="34" charset="-122"/>
-                <a:cs typeface="Yu Gothic" pitchFamily="34" charset="-120"/>
-              </a:rPr>
-              <a:t>STEP 3 ★★★★</a:t>
-            </a:r>
-            <a:endParaRPr lang="en-US" sz="1200" dirty="0"/>
-          </a:p>
-        </p:txBody>
-      </p:sp>
-      <p:sp>
-        <p:nvSpPr>
-          <p:cNvPr id="22" name="Text 20"/>
-          <p:cNvSpPr/>
-          <p:nvPr/>
-        </p:nvSpPr>
-        <p:spPr>
-          <a:xfrm>
-            <a:off x="9450324" y="2807208"/>
-            <a:ext cx="2052828" cy="640080"/>
-          </a:xfrm>
-          <a:prstGeom prst="rect">
-            <a:avLst/>
-          </a:prstGeom>
-          <a:noFill/>
-          <a:ln/>
-        </p:spPr>
-        <p:txBody>
-          <a:bodyPr wrap="square" rtlCol="0" anchor="t"/>
-          <a:lstStyle/>
-          <a:p>
-            <a:pPr indent="0" marL="0">
-              <a:lnSpc>
-                <a:spcPct val="105000"/>
-              </a:lnSpc>
-              <a:buNone/>
-            </a:pPr>
-            <a:r>
-              <a:rPr lang="en-US" sz="1550" b="1" dirty="0">
-                <a:solidFill>
-                  <a:srgbClr val="17223B"/>
-                </a:solidFill>
-                <a:latin typeface="Yu Gothic" pitchFamily="34" charset="0"/>
-                <a:ea typeface="Yu Gothic" pitchFamily="34" charset="-122"/>
-                <a:cs typeface="Yu Gothic" pitchFamily="34" charset="-120"/>
-              </a:rPr>
-              <a:t>⑩ SNS影響力集計</a:t>
-            </a:r>
-            <a:endParaRPr lang="en-US" sz="1550" dirty="0"/>
-          </a:p>
-        </p:txBody>
-      </p:sp>
-      <p:sp>
-        <p:nvSpPr>
-          <p:cNvPr id="23" name="Text 21"/>
-          <p:cNvSpPr/>
-          <p:nvPr/>
-        </p:nvSpPr>
-        <p:spPr>
-          <a:xfrm>
-            <a:off x="9450324" y="3566160"/>
-            <a:ext cx="2052828" cy="777240"/>
-          </a:xfrm>
-          <a:prstGeom prst="rect">
-            <a:avLst/>
-          </a:prstGeom>
-          <a:noFill/>
-          <a:ln/>
-        </p:spPr>
-        <p:txBody>
-          <a:bodyPr wrap="square" rtlCol="0" anchor="t"/>
-          <a:lstStyle/>
-          <a:p>
-            <a:pPr indent="0" marL="0">
-              <a:lnSpc>
-                <a:spcPct val="120000"/>
-              </a:lnSpc>
-              <a:buNone/>
-            </a:pPr>
-            <a:r>
-              <a:rPr lang="en-US" sz="1150" dirty="0">
-                <a:solidFill>
-                  <a:srgbClr val="5D667C"/>
-                </a:solidFill>
-                <a:latin typeface="Yu Gothic" pitchFamily="34" charset="0"/>
-                <a:ea typeface="Yu Gothic" pitchFamily="34" charset="-122"/>
-                <a:cs typeface="Yu Gothic" pitchFamily="34" charset="-120"/>
-              </a:rPr>
-              <a:t>宣伝価値を数値化し、新規営業の武器に。</a:t>
-            </a:r>
-            <a:endParaRPr lang="en-US" sz="1150" dirty="0"/>
-          </a:p>
-        </p:txBody>
-      </p:sp>
-      <p:sp>
-        <p:nvSpPr>
-          <p:cNvPr id="24" name="Shape 22"/>
-          <p:cNvSpPr/>
-          <p:nvPr/>
-        </p:nvSpPr>
-        <p:spPr>
-          <a:xfrm>
-            <a:off x="457200" y="4937760"/>
-            <a:ext cx="11274552" cy="1097280"/>
-          </a:xfrm>
-          <a:prstGeom prst="roundRect">
-            <a:avLst>
-              <a:gd name="adj" fmla="val 7500"/>
-            </a:avLst>
-          </a:prstGeom>
-          <a:solidFill>
-            <a:srgbClr val="FBEEE9"/>
-          </a:solidFill>
-          <a:ln w="12700">
-            <a:solidFill>
-              <a:srgbClr val="EBC7B8"/>
-            </a:solidFill>
-            <a:prstDash val="solid"/>
-          </a:ln>
-        </p:spPr>
-      </p:sp>
-      <p:sp>
-        <p:nvSpPr>
-          <p:cNvPr id="25" name="Shape 23"/>
-          <p:cNvSpPr/>
-          <p:nvPr/>
-        </p:nvSpPr>
-        <p:spPr>
-          <a:xfrm>
-            <a:off x="457200" y="4937760"/>
-            <a:ext cx="82296" cy="1097280"/>
-          </a:xfrm>
-          <a:prstGeom prst="roundRect">
-            <a:avLst>
-              <a:gd name="adj" fmla="val 44444"/>
-            </a:avLst>
-          </a:prstGeom>
-          <a:solidFill>
-            <a:srgbClr val="D9542F"/>
-          </a:solidFill>
-          <a:ln/>
-        </p:spPr>
-      </p:sp>
-      <p:sp>
-        <p:nvSpPr>
-          <p:cNvPr id="26" name="Text 24"/>
-          <p:cNvSpPr/>
-          <p:nvPr/>
-        </p:nvSpPr>
-        <p:spPr>
-          <a:xfrm>
-            <a:off x="731520" y="4937760"/>
-            <a:ext cx="10771632" cy="1097280"/>
-          </a:xfrm>
-          <a:prstGeom prst="rect">
-            <a:avLst/>
-          </a:prstGeom>
-          <a:noFill/>
-          <a:ln/>
-        </p:spPr>
-        <p:txBody>
-          <a:bodyPr wrap="square" rtlCol="0" anchor="ctr"/>
-          <a:lstStyle/>
-          <a:p>
-            <a:pPr indent="0" marL="0">
-              <a:lnSpc>
-                <a:spcPct val="125000"/>
-              </a:lnSpc>
-              <a:buNone/>
-            </a:pPr>
-            <a:r>
-              <a:rPr lang="en-US" sz="1350" dirty="0">
-                <a:solidFill>
-                  <a:srgbClr val="17223B"/>
-                </a:solidFill>
-                <a:latin typeface="Yu Gothic" pitchFamily="34" charset="0"/>
-                <a:ea typeface="Yu Gothic" pitchFamily="34" charset="-122"/>
-                <a:cs typeface="Yu Gothic" pitchFamily="34" charset="-120"/>
-              </a:rPr>
-              <a:t>この3つ（⑨→⑪→⑩）は</a:t>
-            </a:r>
-            <a:pPr indent="0" marL="0">
-              <a:lnSpc>
-                <a:spcPct val="125000"/>
-              </a:lnSpc>
-              <a:buNone/>
-            </a:pPr>
-            <a:r>
-              <a:rPr lang="en-US" sz="1350" b="1" dirty="0">
-                <a:solidFill>
-                  <a:srgbClr val="B7431F"/>
-                </a:solidFill>
-                <a:latin typeface="Yu Gothic" pitchFamily="34" charset="0"/>
-                <a:ea typeface="Yu Gothic" pitchFamily="34" charset="-122"/>
-                <a:cs typeface="Yu Gothic" pitchFamily="34" charset="-120"/>
-              </a:rPr>
-              <a:t>収益に直結する「最優先」機能</a:t>
-            </a:r>
-            <a:pPr indent="0" marL="0">
-              <a:lnSpc>
-                <a:spcPct val="125000"/>
-              </a:lnSpc>
-              <a:buNone/>
-            </a:pPr>
-            <a:r>
-              <a:rPr lang="en-US" sz="1350" dirty="0">
-                <a:solidFill>
-                  <a:srgbClr val="17223B"/>
-                </a:solidFill>
-                <a:latin typeface="Yu Gothic" pitchFamily="34" charset="0"/>
-                <a:ea typeface="Yu Gothic" pitchFamily="34" charset="-122"/>
-                <a:cs typeface="Yu Gothic" pitchFamily="34" charset="-120"/>
-              </a:rPr>
-              <a:t>。スモールスタートの上に、この順で載せていくのがおすすめです。</a:t>
-            </a:r>
-            <a:endParaRPr lang="en-US" sz="1350" dirty="0"/>
           </a:p>
         </p:txBody>
       </p:sp>
@@ -3278,6 +4063,997 @@
 <file path=ppt/slides/slide11.xml><?xml version="1.0" encoding="utf-8"?>
 <p:sld xmlns:a="http://schemas.openxmlformats.org/drawingml/2006/main" xmlns:r="http://schemas.openxmlformats.org/officeDocument/2006/relationships" xmlns:p="http://schemas.openxmlformats.org/presentationml/2006/main">
   <p:cSld name="Slide 11">
+    <p:bg>
+      <p:bgPr>
+        <a:solidFill>
+          <a:srgbClr val="FFFFFF"/>
+        </a:solidFill>
+      </p:bgPr>
+    </p:bg>
+    <p:spTree>
+      <p:nvGrpSpPr>
+        <p:cNvPr id="1" name=""/>
+        <p:cNvGrpSpPr/>
+        <p:nvPr/>
+      </p:nvGrpSpPr>
+      <p:grpSpPr>
+        <a:xfrm>
+          <a:off x="0" y="0"/>
+          <a:ext cx="0" cy="0"/>
+          <a:chOff x="0" y="0"/>
+          <a:chExt cx="0" cy="0"/>
+        </a:xfrm>
+      </p:grpSpPr>
+      <p:sp>
+        <p:nvSpPr>
+          <p:cNvPr id="2" name="Text 0"/>
+          <p:cNvSpPr/>
+          <p:nvPr/>
+        </p:nvSpPr>
+        <p:spPr>
+          <a:xfrm>
+            <a:off x="457200" y="384048"/>
+            <a:ext cx="11274552" cy="274320"/>
+          </a:xfrm>
+          <a:prstGeom prst="rect">
+            <a:avLst/>
+          </a:prstGeom>
+          <a:noFill/>
+          <a:ln/>
+        </p:spPr>
+        <p:txBody>
+          <a:bodyPr wrap="square" rtlCol="0" anchor="ctr"/>
+          <a:lstStyle/>
+          <a:p>
+            <a:pPr indent="0" marL="0">
+              <a:buNone/>
+            </a:pPr>
+            <a:r>
+              <a:rPr lang="en-US" sz="1100" b="1" spc="200" kern="0" dirty="0">
+                <a:solidFill>
+                  <a:srgbClr val="B7431F"/>
+                </a:solidFill>
+                <a:latin typeface="Yu Gothic" pitchFamily="34" charset="0"/>
+                <a:ea typeface="Yu Gothic" pitchFamily="34" charset="-122"/>
+                <a:cs typeface="Yu Gothic" pitchFamily="34" charset="-120"/>
+              </a:rPr>
+              <a:t>04 · おすすめの進め方</a:t>
+            </a:r>
+            <a:endParaRPr lang="en-US" sz="1100" dirty="0"/>
+          </a:p>
+        </p:txBody>
+      </p:sp>
+      <p:sp>
+        <p:nvSpPr>
+          <p:cNvPr id="3" name="Text 1"/>
+          <p:cNvSpPr/>
+          <p:nvPr/>
+        </p:nvSpPr>
+        <p:spPr>
+          <a:xfrm>
+            <a:off x="457200" y="676656"/>
+            <a:ext cx="11274552" cy="658368"/>
+          </a:xfrm>
+          <a:prstGeom prst="rect">
+            <a:avLst/>
+          </a:prstGeom>
+          <a:noFill/>
+          <a:ln/>
+        </p:spPr>
+        <p:txBody>
+          <a:bodyPr wrap="square" rtlCol="0" anchor="ctr"/>
+          <a:lstStyle/>
+          <a:p>
+            <a:pPr indent="0" marL="0">
+              <a:buNone/>
+            </a:pPr>
+            <a:r>
+              <a:rPr lang="en-US" sz="2700" b="1" dirty="0">
+                <a:solidFill>
+                  <a:srgbClr val="17223B"/>
+                </a:solidFill>
+                <a:latin typeface="Yu Gothic" pitchFamily="34" charset="0"/>
+                <a:ea typeface="Yu Gothic" pitchFamily="34" charset="-122"/>
+                <a:cs typeface="Yu Gothic" pitchFamily="34" charset="-120"/>
+              </a:rPr>
+              <a:t>まず土台。効果を確かめて、収益直結の順に足す</a:t>
+            </a:r>
+            <a:endParaRPr lang="en-US" sz="2700" dirty="0"/>
+          </a:p>
+        </p:txBody>
+      </p:sp>
+      <p:sp>
+        <p:nvSpPr>
+          <p:cNvPr id="4" name="Text 2"/>
+          <p:cNvSpPr/>
+          <p:nvPr/>
+        </p:nvSpPr>
+        <p:spPr>
+          <a:xfrm>
+            <a:off x="457200" y="1371600"/>
+            <a:ext cx="11247120" cy="320040"/>
+          </a:xfrm>
+          <a:prstGeom prst="rect">
+            <a:avLst/>
+          </a:prstGeom>
+          <a:noFill/>
+          <a:ln/>
+        </p:spPr>
+        <p:txBody>
+          <a:bodyPr wrap="square" rtlCol="0" anchor="ctr"/>
+          <a:lstStyle/>
+          <a:p>
+            <a:pPr indent="0" marL="0">
+              <a:buNone/>
+            </a:pPr>
+            <a:r>
+              <a:rPr lang="en-US" sz="1350" dirty="0">
+                <a:solidFill>
+                  <a:srgbClr val="5D667C"/>
+                </a:solidFill>
+                <a:latin typeface="Yu Gothic" pitchFamily="34" charset="0"/>
+                <a:ea typeface="Yu Gothic" pitchFamily="34" charset="-122"/>
+                <a:cs typeface="Yu Gothic" pitchFamily="34" charset="-120"/>
+              </a:rPr>
+              <a:t>初期投資を抑えつつ、効果を確かめながら次を判断できます。</a:t>
+            </a:r>
+            <a:endParaRPr lang="en-US" sz="1350" dirty="0"/>
+          </a:p>
+        </p:txBody>
+      </p:sp>
+      <p:sp>
+        <p:nvSpPr>
+          <p:cNvPr id="5" name="Shape 3"/>
+          <p:cNvSpPr/>
+          <p:nvPr/>
+        </p:nvSpPr>
+        <p:spPr>
+          <a:xfrm>
+            <a:off x="457200" y="2148840"/>
+            <a:ext cx="2510028" cy="2286000"/>
+          </a:xfrm>
+          <a:prstGeom prst="roundRect">
+            <a:avLst>
+              <a:gd name="adj" fmla="val 4000"/>
+            </a:avLst>
+          </a:prstGeom>
+          <a:solidFill>
+            <a:srgbClr val="F7F5F0"/>
+          </a:solidFill>
+          <a:ln w="12700">
+            <a:solidFill>
+              <a:srgbClr val="E4DFD3"/>
+            </a:solidFill>
+            <a:prstDash val="solid"/>
+          </a:ln>
+        </p:spPr>
+      </p:sp>
+      <p:sp>
+        <p:nvSpPr>
+          <p:cNvPr id="6" name="Text 4"/>
+          <p:cNvSpPr/>
+          <p:nvPr/>
+        </p:nvSpPr>
+        <p:spPr>
+          <a:xfrm>
+            <a:off x="685800" y="2404872"/>
+            <a:ext cx="2052828" cy="320040"/>
+          </a:xfrm>
+          <a:prstGeom prst="rect">
+            <a:avLst/>
+          </a:prstGeom>
+          <a:noFill/>
+          <a:ln/>
+        </p:spPr>
+        <p:txBody>
+          <a:bodyPr wrap="square" rtlCol="0" anchor="ctr"/>
+          <a:lstStyle/>
+          <a:p>
+            <a:pPr indent="0" marL="0">
+              <a:buNone/>
+            </a:pPr>
+            <a:r>
+              <a:rPr lang="en-US" sz="1200" b="1" spc="50" kern="0" dirty="0">
+                <a:solidFill>
+                  <a:srgbClr val="5D667C"/>
+                </a:solidFill>
+                <a:latin typeface="Yu Gothic" pitchFamily="34" charset="0"/>
+                <a:ea typeface="Yu Gothic" pitchFamily="34" charset="-122"/>
+                <a:cs typeface="Yu Gothic" pitchFamily="34" charset="-120"/>
+              </a:rPr>
+              <a:t>STEP 0</a:t>
+            </a:r>
+            <a:endParaRPr lang="en-US" sz="1200" dirty="0"/>
+          </a:p>
+        </p:txBody>
+      </p:sp>
+      <p:sp>
+        <p:nvSpPr>
+          <p:cNvPr id="7" name="Text 5"/>
+          <p:cNvSpPr/>
+          <p:nvPr/>
+        </p:nvSpPr>
+        <p:spPr>
+          <a:xfrm>
+            <a:off x="685800" y="2807208"/>
+            <a:ext cx="2052828" cy="640080"/>
+          </a:xfrm>
+          <a:prstGeom prst="rect">
+            <a:avLst/>
+          </a:prstGeom>
+          <a:noFill/>
+          <a:ln/>
+        </p:spPr>
+        <p:txBody>
+          <a:bodyPr wrap="square" rtlCol="0" anchor="t"/>
+          <a:lstStyle/>
+          <a:p>
+            <a:pPr indent="0" marL="0">
+              <a:lnSpc>
+                <a:spcPct val="105000"/>
+              </a:lnSpc>
+              <a:buNone/>
+            </a:pPr>
+            <a:r>
+              <a:rPr lang="en-US" sz="1550" b="1" dirty="0">
+                <a:solidFill>
+                  <a:srgbClr val="17223B"/>
+                </a:solidFill>
+                <a:latin typeface="Yu Gothic" pitchFamily="34" charset="0"/>
+                <a:ea typeface="Yu Gothic" pitchFamily="34" charset="-122"/>
+                <a:cs typeface="Yu Gothic" pitchFamily="34" charset="-120"/>
+              </a:rPr>
+              <a:t>スモールスタート</a:t>
+            </a:r>
+            <a:endParaRPr lang="en-US" sz="1550" dirty="0"/>
+          </a:p>
+        </p:txBody>
+      </p:sp>
+      <p:sp>
+        <p:nvSpPr>
+          <p:cNvPr id="8" name="Text 6"/>
+          <p:cNvSpPr/>
+          <p:nvPr/>
+        </p:nvSpPr>
+        <p:spPr>
+          <a:xfrm>
+            <a:off x="685800" y="3566160"/>
+            <a:ext cx="2052828" cy="777240"/>
+          </a:xfrm>
+          <a:prstGeom prst="rect">
+            <a:avLst/>
+          </a:prstGeom>
+          <a:noFill/>
+          <a:ln/>
+        </p:spPr>
+        <p:txBody>
+          <a:bodyPr wrap="square" rtlCol="0" anchor="t"/>
+          <a:lstStyle/>
+          <a:p>
+            <a:pPr indent="0" marL="0">
+              <a:lnSpc>
+                <a:spcPct val="120000"/>
+              </a:lnSpc>
+              <a:buNone/>
+            </a:pPr>
+            <a:r>
+              <a:rPr lang="en-US" sz="1150" dirty="0">
+                <a:solidFill>
+                  <a:srgbClr val="5D667C"/>
+                </a:solidFill>
+                <a:latin typeface="Yu Gothic" pitchFamily="34" charset="0"/>
+                <a:ea typeface="Yu Gothic" pitchFamily="34" charset="-122"/>
+                <a:cs typeface="Yu Gothic" pitchFamily="34" charset="-120"/>
+              </a:rPr>
+              <a:t>土台のみ・約100万＋月10万で走り始める。</a:t>
+            </a:r>
+            <a:endParaRPr lang="en-US" sz="1150" dirty="0"/>
+          </a:p>
+        </p:txBody>
+      </p:sp>
+      <p:sp>
+        <p:nvSpPr>
+          <p:cNvPr id="9" name="Text 7"/>
+          <p:cNvSpPr/>
+          <p:nvPr/>
+        </p:nvSpPr>
+        <p:spPr>
+          <a:xfrm>
+            <a:off x="2948940" y="2148840"/>
+            <a:ext cx="411480" cy="2286000"/>
+          </a:xfrm>
+          <a:prstGeom prst="rect">
+            <a:avLst/>
+          </a:prstGeom>
+          <a:noFill/>
+          <a:ln/>
+        </p:spPr>
+        <p:txBody>
+          <a:bodyPr wrap="square" rtlCol="0" anchor="ctr"/>
+          <a:lstStyle/>
+          <a:p>
+            <a:pPr algn="ctr" indent="0" marL="0">
+              <a:buNone/>
+            </a:pPr>
+            <a:r>
+              <a:rPr lang="en-US" sz="2200" b="1" dirty="0">
+                <a:solidFill>
+                  <a:srgbClr val="D9542F"/>
+                </a:solidFill>
+                <a:latin typeface="Yu Gothic" pitchFamily="34" charset="0"/>
+                <a:ea typeface="Yu Gothic" pitchFamily="34" charset="-122"/>
+                <a:cs typeface="Yu Gothic" pitchFamily="34" charset="-120"/>
+              </a:rPr>
+              <a:t>→</a:t>
+            </a:r>
+            <a:endParaRPr lang="en-US" sz="2200" dirty="0"/>
+          </a:p>
+        </p:txBody>
+      </p:sp>
+      <p:sp>
+        <p:nvSpPr>
+          <p:cNvPr id="10" name="Shape 8"/>
+          <p:cNvSpPr/>
+          <p:nvPr/>
+        </p:nvSpPr>
+        <p:spPr>
+          <a:xfrm>
+            <a:off x="3378708" y="2148840"/>
+            <a:ext cx="2510028" cy="2286000"/>
+          </a:xfrm>
+          <a:prstGeom prst="roundRect">
+            <a:avLst>
+              <a:gd name="adj" fmla="val 4000"/>
+            </a:avLst>
+          </a:prstGeom>
+          <a:solidFill>
+            <a:srgbClr val="F7F5F0"/>
+          </a:solidFill>
+          <a:ln w="12700">
+            <a:solidFill>
+              <a:srgbClr val="E4DFD3"/>
+            </a:solidFill>
+            <a:prstDash val="solid"/>
+          </a:ln>
+        </p:spPr>
+      </p:sp>
+      <p:sp>
+        <p:nvSpPr>
+          <p:cNvPr id="11" name="Text 9"/>
+          <p:cNvSpPr/>
+          <p:nvPr/>
+        </p:nvSpPr>
+        <p:spPr>
+          <a:xfrm>
+            <a:off x="3607308" y="2404872"/>
+            <a:ext cx="2052828" cy="320040"/>
+          </a:xfrm>
+          <a:prstGeom prst="rect">
+            <a:avLst/>
+          </a:prstGeom>
+          <a:noFill/>
+          <a:ln/>
+        </p:spPr>
+        <p:txBody>
+          <a:bodyPr wrap="square" rtlCol="0" anchor="ctr"/>
+          <a:lstStyle/>
+          <a:p>
+            <a:pPr indent="0" marL="0">
+              <a:buNone/>
+            </a:pPr>
+            <a:r>
+              <a:rPr lang="en-US" sz="1200" b="1" spc="50" kern="0" dirty="0">
+                <a:solidFill>
+                  <a:srgbClr val="B7431F"/>
+                </a:solidFill>
+                <a:latin typeface="Yu Gothic" pitchFamily="34" charset="0"/>
+                <a:ea typeface="Yu Gothic" pitchFamily="34" charset="-122"/>
+                <a:cs typeface="Yu Gothic" pitchFamily="34" charset="-120"/>
+              </a:rPr>
+              <a:t>STEP 1 ★★★★★</a:t>
+            </a:r>
+            <a:endParaRPr lang="en-US" sz="1200" dirty="0"/>
+          </a:p>
+        </p:txBody>
+      </p:sp>
+      <p:sp>
+        <p:nvSpPr>
+          <p:cNvPr id="12" name="Text 10"/>
+          <p:cNvSpPr/>
+          <p:nvPr/>
+        </p:nvSpPr>
+        <p:spPr>
+          <a:xfrm>
+            <a:off x="3607308" y="2807208"/>
+            <a:ext cx="2052828" cy="640080"/>
+          </a:xfrm>
+          <a:prstGeom prst="rect">
+            <a:avLst/>
+          </a:prstGeom>
+          <a:noFill/>
+          <a:ln/>
+        </p:spPr>
+        <p:txBody>
+          <a:bodyPr wrap="square" rtlCol="0" anchor="t"/>
+          <a:lstStyle/>
+          <a:p>
+            <a:pPr indent="0" marL="0">
+              <a:lnSpc>
+                <a:spcPct val="105000"/>
+              </a:lnSpc>
+              <a:buNone/>
+            </a:pPr>
+            <a:r>
+              <a:rPr lang="en-US" sz="1550" b="1" dirty="0">
+                <a:solidFill>
+                  <a:srgbClr val="17223B"/>
+                </a:solidFill>
+                <a:latin typeface="Yu Gothic" pitchFamily="34" charset="0"/>
+                <a:ea typeface="Yu Gothic" pitchFamily="34" charset="-122"/>
+                <a:cs typeface="Yu Gothic" pitchFamily="34" charset="-120"/>
+              </a:rPr>
+              <a:t>⑨ 契約更新アラート</a:t>
+            </a:r>
+            <a:endParaRPr lang="en-US" sz="1550" dirty="0"/>
+          </a:p>
+        </p:txBody>
+      </p:sp>
+      <p:sp>
+        <p:nvSpPr>
+          <p:cNvPr id="13" name="Text 11"/>
+          <p:cNvSpPr/>
+          <p:nvPr/>
+        </p:nvSpPr>
+        <p:spPr>
+          <a:xfrm>
+            <a:off x="3607308" y="3566160"/>
+            <a:ext cx="2052828" cy="777240"/>
+          </a:xfrm>
+          <a:prstGeom prst="rect">
+            <a:avLst/>
+          </a:prstGeom>
+          <a:noFill/>
+          <a:ln/>
+        </p:spPr>
+        <p:txBody>
+          <a:bodyPr wrap="square" rtlCol="0" anchor="t"/>
+          <a:lstStyle/>
+          <a:p>
+            <a:pPr indent="0" marL="0">
+              <a:lnSpc>
+                <a:spcPct val="120000"/>
+              </a:lnSpc>
+              <a:buNone/>
+            </a:pPr>
+            <a:r>
+              <a:rPr lang="en-US" sz="1150" dirty="0">
+                <a:solidFill>
+                  <a:srgbClr val="5D667C"/>
+                </a:solidFill>
+                <a:latin typeface="Yu Gothic" pitchFamily="34" charset="0"/>
+                <a:ea typeface="Yu Gothic" pitchFamily="34" charset="-122"/>
+                <a:cs typeface="Yu Gothic" pitchFamily="34" charset="-120"/>
+              </a:rPr>
+              <a:t>うっかり失注を防ぎ、まず「守り」を固める。</a:t>
+            </a:r>
+            <a:endParaRPr lang="en-US" sz="1150" dirty="0"/>
+          </a:p>
+        </p:txBody>
+      </p:sp>
+      <p:sp>
+        <p:nvSpPr>
+          <p:cNvPr id="14" name="Text 12"/>
+          <p:cNvSpPr/>
+          <p:nvPr/>
+        </p:nvSpPr>
+        <p:spPr>
+          <a:xfrm>
+            <a:off x="5870448" y="2148840"/>
+            <a:ext cx="411480" cy="2286000"/>
+          </a:xfrm>
+          <a:prstGeom prst="rect">
+            <a:avLst/>
+          </a:prstGeom>
+          <a:noFill/>
+          <a:ln/>
+        </p:spPr>
+        <p:txBody>
+          <a:bodyPr wrap="square" rtlCol="0" anchor="ctr"/>
+          <a:lstStyle/>
+          <a:p>
+            <a:pPr algn="ctr" indent="0" marL="0">
+              <a:buNone/>
+            </a:pPr>
+            <a:r>
+              <a:rPr lang="en-US" sz="2200" b="1" dirty="0">
+                <a:solidFill>
+                  <a:srgbClr val="D9542F"/>
+                </a:solidFill>
+                <a:latin typeface="Yu Gothic" pitchFamily="34" charset="0"/>
+                <a:ea typeface="Yu Gothic" pitchFamily="34" charset="-122"/>
+                <a:cs typeface="Yu Gothic" pitchFamily="34" charset="-120"/>
+              </a:rPr>
+              <a:t>→</a:t>
+            </a:r>
+            <a:endParaRPr lang="en-US" sz="2200" dirty="0"/>
+          </a:p>
+        </p:txBody>
+      </p:sp>
+      <p:sp>
+        <p:nvSpPr>
+          <p:cNvPr id="15" name="Shape 13"/>
+          <p:cNvSpPr/>
+          <p:nvPr/>
+        </p:nvSpPr>
+        <p:spPr>
+          <a:xfrm>
+            <a:off x="6300216" y="2148840"/>
+            <a:ext cx="2510028" cy="2286000"/>
+          </a:xfrm>
+          <a:prstGeom prst="roundRect">
+            <a:avLst>
+              <a:gd name="adj" fmla="val 4000"/>
+            </a:avLst>
+          </a:prstGeom>
+          <a:solidFill>
+            <a:srgbClr val="F7F5F0"/>
+          </a:solidFill>
+          <a:ln w="12700">
+            <a:solidFill>
+              <a:srgbClr val="E4DFD3"/>
+            </a:solidFill>
+            <a:prstDash val="solid"/>
+          </a:ln>
+        </p:spPr>
+      </p:sp>
+      <p:sp>
+        <p:nvSpPr>
+          <p:cNvPr id="16" name="Text 14"/>
+          <p:cNvSpPr/>
+          <p:nvPr/>
+        </p:nvSpPr>
+        <p:spPr>
+          <a:xfrm>
+            <a:off x="6528816" y="2404872"/>
+            <a:ext cx="2052828" cy="320040"/>
+          </a:xfrm>
+          <a:prstGeom prst="rect">
+            <a:avLst/>
+          </a:prstGeom>
+          <a:noFill/>
+          <a:ln/>
+        </p:spPr>
+        <p:txBody>
+          <a:bodyPr wrap="square" rtlCol="0" anchor="ctr"/>
+          <a:lstStyle/>
+          <a:p>
+            <a:pPr indent="0" marL="0">
+              <a:buNone/>
+            </a:pPr>
+            <a:r>
+              <a:rPr lang="en-US" sz="1200" b="1" spc="50" kern="0" dirty="0">
+                <a:solidFill>
+                  <a:srgbClr val="CF9526"/>
+                </a:solidFill>
+                <a:latin typeface="Yu Gothic" pitchFamily="34" charset="0"/>
+                <a:ea typeface="Yu Gothic" pitchFamily="34" charset="-122"/>
+                <a:cs typeface="Yu Gothic" pitchFamily="34" charset="-120"/>
+              </a:rPr>
+              <a:t>STEP 2 ★★★★</a:t>
+            </a:r>
+            <a:endParaRPr lang="en-US" sz="1200" dirty="0"/>
+          </a:p>
+        </p:txBody>
+      </p:sp>
+      <p:sp>
+        <p:nvSpPr>
+          <p:cNvPr id="17" name="Text 15"/>
+          <p:cNvSpPr/>
+          <p:nvPr/>
+        </p:nvSpPr>
+        <p:spPr>
+          <a:xfrm>
+            <a:off x="6528816" y="2807208"/>
+            <a:ext cx="2052828" cy="640080"/>
+          </a:xfrm>
+          <a:prstGeom prst="rect">
+            <a:avLst/>
+          </a:prstGeom>
+          <a:noFill/>
+          <a:ln/>
+        </p:spPr>
+        <p:txBody>
+          <a:bodyPr wrap="square" rtlCol="0" anchor="t"/>
+          <a:lstStyle/>
+          <a:p>
+            <a:pPr indent="0" marL="0">
+              <a:lnSpc>
+                <a:spcPct val="105000"/>
+              </a:lnSpc>
+              <a:buNone/>
+            </a:pPr>
+            <a:r>
+              <a:rPr lang="en-US" sz="1550" b="1" dirty="0">
+                <a:solidFill>
+                  <a:srgbClr val="17223B"/>
+                </a:solidFill>
+                <a:latin typeface="Yu Gothic" pitchFamily="34" charset="0"/>
+                <a:ea typeface="Yu Gothic" pitchFamily="34" charset="-122"/>
+                <a:cs typeface="Yu Gothic" pitchFamily="34" charset="-120"/>
+              </a:rPr>
+              <a:t>⑪ ROI・露出レポート</a:t>
+            </a:r>
+            <a:endParaRPr lang="en-US" sz="1550" dirty="0"/>
+          </a:p>
+        </p:txBody>
+      </p:sp>
+      <p:sp>
+        <p:nvSpPr>
+          <p:cNvPr id="18" name="Text 16"/>
+          <p:cNvSpPr/>
+          <p:nvPr/>
+        </p:nvSpPr>
+        <p:spPr>
+          <a:xfrm>
+            <a:off x="6528816" y="3566160"/>
+            <a:ext cx="2052828" cy="777240"/>
+          </a:xfrm>
+          <a:prstGeom prst="rect">
+            <a:avLst/>
+          </a:prstGeom>
+          <a:noFill/>
+          <a:ln/>
+        </p:spPr>
+        <p:txBody>
+          <a:bodyPr wrap="square" rtlCol="0" anchor="t"/>
+          <a:lstStyle/>
+          <a:p>
+            <a:pPr indent="0" marL="0">
+              <a:lnSpc>
+                <a:spcPct val="120000"/>
+              </a:lnSpc>
+              <a:buNone/>
+            </a:pPr>
+            <a:r>
+              <a:rPr lang="en-US" sz="1150" dirty="0">
+                <a:solidFill>
+                  <a:srgbClr val="5D667C"/>
+                </a:solidFill>
+                <a:latin typeface="Yu Gothic" pitchFamily="34" charset="0"/>
+                <a:ea typeface="Yu Gothic" pitchFamily="34" charset="-122"/>
+                <a:cs typeface="Yu Gothic" pitchFamily="34" charset="-120"/>
+              </a:rPr>
+              <a:t>効果を見せて、継続（更新）の決め手に。</a:t>
+            </a:r>
+            <a:endParaRPr lang="en-US" sz="1150" dirty="0"/>
+          </a:p>
+        </p:txBody>
+      </p:sp>
+      <p:sp>
+        <p:nvSpPr>
+          <p:cNvPr id="19" name="Text 17"/>
+          <p:cNvSpPr/>
+          <p:nvPr/>
+        </p:nvSpPr>
+        <p:spPr>
+          <a:xfrm>
+            <a:off x="8791956" y="2148840"/>
+            <a:ext cx="411480" cy="2286000"/>
+          </a:xfrm>
+          <a:prstGeom prst="rect">
+            <a:avLst/>
+          </a:prstGeom>
+          <a:noFill/>
+          <a:ln/>
+        </p:spPr>
+        <p:txBody>
+          <a:bodyPr wrap="square" rtlCol="0" anchor="ctr"/>
+          <a:lstStyle/>
+          <a:p>
+            <a:pPr algn="ctr" indent="0" marL="0">
+              <a:buNone/>
+            </a:pPr>
+            <a:r>
+              <a:rPr lang="en-US" sz="2200" b="1" dirty="0">
+                <a:solidFill>
+                  <a:srgbClr val="D9542F"/>
+                </a:solidFill>
+                <a:latin typeface="Yu Gothic" pitchFamily="34" charset="0"/>
+                <a:ea typeface="Yu Gothic" pitchFamily="34" charset="-122"/>
+                <a:cs typeface="Yu Gothic" pitchFamily="34" charset="-120"/>
+              </a:rPr>
+              <a:t>→</a:t>
+            </a:r>
+            <a:endParaRPr lang="en-US" sz="2200" dirty="0"/>
+          </a:p>
+        </p:txBody>
+      </p:sp>
+      <p:sp>
+        <p:nvSpPr>
+          <p:cNvPr id="20" name="Shape 18"/>
+          <p:cNvSpPr/>
+          <p:nvPr/>
+        </p:nvSpPr>
+        <p:spPr>
+          <a:xfrm>
+            <a:off x="9221724" y="2148840"/>
+            <a:ext cx="2510028" cy="2286000"/>
+          </a:xfrm>
+          <a:prstGeom prst="roundRect">
+            <a:avLst>
+              <a:gd name="adj" fmla="val 4000"/>
+            </a:avLst>
+          </a:prstGeom>
+          <a:solidFill>
+            <a:srgbClr val="F7F5F0"/>
+          </a:solidFill>
+          <a:ln w="12700">
+            <a:solidFill>
+              <a:srgbClr val="E4DFD3"/>
+            </a:solidFill>
+            <a:prstDash val="solid"/>
+          </a:ln>
+        </p:spPr>
+      </p:sp>
+      <p:sp>
+        <p:nvSpPr>
+          <p:cNvPr id="21" name="Text 19"/>
+          <p:cNvSpPr/>
+          <p:nvPr/>
+        </p:nvSpPr>
+        <p:spPr>
+          <a:xfrm>
+            <a:off x="9450324" y="2404872"/>
+            <a:ext cx="2052828" cy="320040"/>
+          </a:xfrm>
+          <a:prstGeom prst="rect">
+            <a:avLst/>
+          </a:prstGeom>
+          <a:noFill/>
+          <a:ln/>
+        </p:spPr>
+        <p:txBody>
+          <a:bodyPr wrap="square" rtlCol="0" anchor="ctr"/>
+          <a:lstStyle/>
+          <a:p>
+            <a:pPr indent="0" marL="0">
+              <a:buNone/>
+            </a:pPr>
+            <a:r>
+              <a:rPr lang="en-US" sz="1200" b="1" spc="50" kern="0" dirty="0">
+                <a:solidFill>
+                  <a:srgbClr val="CF9526"/>
+                </a:solidFill>
+                <a:latin typeface="Yu Gothic" pitchFamily="34" charset="0"/>
+                <a:ea typeface="Yu Gothic" pitchFamily="34" charset="-122"/>
+                <a:cs typeface="Yu Gothic" pitchFamily="34" charset="-120"/>
+              </a:rPr>
+              <a:t>STEP 3 ★★★★</a:t>
+            </a:r>
+            <a:endParaRPr lang="en-US" sz="1200" dirty="0"/>
+          </a:p>
+        </p:txBody>
+      </p:sp>
+      <p:sp>
+        <p:nvSpPr>
+          <p:cNvPr id="22" name="Text 20"/>
+          <p:cNvSpPr/>
+          <p:nvPr/>
+        </p:nvSpPr>
+        <p:spPr>
+          <a:xfrm>
+            <a:off x="9450324" y="2807208"/>
+            <a:ext cx="2052828" cy="640080"/>
+          </a:xfrm>
+          <a:prstGeom prst="rect">
+            <a:avLst/>
+          </a:prstGeom>
+          <a:noFill/>
+          <a:ln/>
+        </p:spPr>
+        <p:txBody>
+          <a:bodyPr wrap="square" rtlCol="0" anchor="t"/>
+          <a:lstStyle/>
+          <a:p>
+            <a:pPr indent="0" marL="0">
+              <a:lnSpc>
+                <a:spcPct val="105000"/>
+              </a:lnSpc>
+              <a:buNone/>
+            </a:pPr>
+            <a:r>
+              <a:rPr lang="en-US" sz="1550" b="1" dirty="0">
+                <a:solidFill>
+                  <a:srgbClr val="17223B"/>
+                </a:solidFill>
+                <a:latin typeface="Yu Gothic" pitchFamily="34" charset="0"/>
+                <a:ea typeface="Yu Gothic" pitchFamily="34" charset="-122"/>
+                <a:cs typeface="Yu Gothic" pitchFamily="34" charset="-120"/>
+              </a:rPr>
+              <a:t>⑩ SNS影響力集計</a:t>
+            </a:r>
+            <a:endParaRPr lang="en-US" sz="1550" dirty="0"/>
+          </a:p>
+        </p:txBody>
+      </p:sp>
+      <p:sp>
+        <p:nvSpPr>
+          <p:cNvPr id="23" name="Text 21"/>
+          <p:cNvSpPr/>
+          <p:nvPr/>
+        </p:nvSpPr>
+        <p:spPr>
+          <a:xfrm>
+            <a:off x="9450324" y="3566160"/>
+            <a:ext cx="2052828" cy="777240"/>
+          </a:xfrm>
+          <a:prstGeom prst="rect">
+            <a:avLst/>
+          </a:prstGeom>
+          <a:noFill/>
+          <a:ln/>
+        </p:spPr>
+        <p:txBody>
+          <a:bodyPr wrap="square" rtlCol="0" anchor="t"/>
+          <a:lstStyle/>
+          <a:p>
+            <a:pPr indent="0" marL="0">
+              <a:lnSpc>
+                <a:spcPct val="120000"/>
+              </a:lnSpc>
+              <a:buNone/>
+            </a:pPr>
+            <a:r>
+              <a:rPr lang="en-US" sz="1150" dirty="0">
+                <a:solidFill>
+                  <a:srgbClr val="5D667C"/>
+                </a:solidFill>
+                <a:latin typeface="Yu Gothic" pitchFamily="34" charset="0"/>
+                <a:ea typeface="Yu Gothic" pitchFamily="34" charset="-122"/>
+                <a:cs typeface="Yu Gothic" pitchFamily="34" charset="-120"/>
+              </a:rPr>
+              <a:t>宣伝価値を数値化し、新規営業の武器に。</a:t>
+            </a:r>
+            <a:endParaRPr lang="en-US" sz="1150" dirty="0"/>
+          </a:p>
+        </p:txBody>
+      </p:sp>
+      <p:sp>
+        <p:nvSpPr>
+          <p:cNvPr id="24" name="Shape 22"/>
+          <p:cNvSpPr/>
+          <p:nvPr/>
+        </p:nvSpPr>
+        <p:spPr>
+          <a:xfrm>
+            <a:off x="457200" y="4937760"/>
+            <a:ext cx="11274552" cy="1097280"/>
+          </a:xfrm>
+          <a:prstGeom prst="roundRect">
+            <a:avLst>
+              <a:gd name="adj" fmla="val 7500"/>
+            </a:avLst>
+          </a:prstGeom>
+          <a:solidFill>
+            <a:srgbClr val="FBEEE9"/>
+          </a:solidFill>
+          <a:ln w="12700">
+            <a:solidFill>
+              <a:srgbClr val="EBC7B8"/>
+            </a:solidFill>
+            <a:prstDash val="solid"/>
+          </a:ln>
+        </p:spPr>
+      </p:sp>
+      <p:sp>
+        <p:nvSpPr>
+          <p:cNvPr id="25" name="Shape 23"/>
+          <p:cNvSpPr/>
+          <p:nvPr/>
+        </p:nvSpPr>
+        <p:spPr>
+          <a:xfrm>
+            <a:off x="457200" y="4937760"/>
+            <a:ext cx="82296" cy="1097280"/>
+          </a:xfrm>
+          <a:prstGeom prst="roundRect">
+            <a:avLst>
+              <a:gd name="adj" fmla="val 44444"/>
+            </a:avLst>
+          </a:prstGeom>
+          <a:solidFill>
+            <a:srgbClr val="D9542F"/>
+          </a:solidFill>
+          <a:ln/>
+        </p:spPr>
+      </p:sp>
+      <p:sp>
+        <p:nvSpPr>
+          <p:cNvPr id="26" name="Text 24"/>
+          <p:cNvSpPr/>
+          <p:nvPr/>
+        </p:nvSpPr>
+        <p:spPr>
+          <a:xfrm>
+            <a:off x="731520" y="4937760"/>
+            <a:ext cx="10771632" cy="1097280"/>
+          </a:xfrm>
+          <a:prstGeom prst="rect">
+            <a:avLst/>
+          </a:prstGeom>
+          <a:noFill/>
+          <a:ln/>
+        </p:spPr>
+        <p:txBody>
+          <a:bodyPr wrap="square" rtlCol="0" anchor="ctr"/>
+          <a:lstStyle/>
+          <a:p>
+            <a:pPr indent="0" marL="0">
+              <a:lnSpc>
+                <a:spcPct val="125000"/>
+              </a:lnSpc>
+              <a:buNone/>
+            </a:pPr>
+            <a:r>
+              <a:rPr lang="en-US" sz="1350" dirty="0">
+                <a:solidFill>
+                  <a:srgbClr val="17223B"/>
+                </a:solidFill>
+                <a:latin typeface="Yu Gothic" pitchFamily="34" charset="0"/>
+                <a:ea typeface="Yu Gothic" pitchFamily="34" charset="-122"/>
+                <a:cs typeface="Yu Gothic" pitchFamily="34" charset="-120"/>
+              </a:rPr>
+              <a:t>この3つ（⑨→⑪→⑩）は</a:t>
+            </a:r>
+            <a:pPr indent="0" marL="0">
+              <a:lnSpc>
+                <a:spcPct val="125000"/>
+              </a:lnSpc>
+              <a:buNone/>
+            </a:pPr>
+            <a:r>
+              <a:rPr lang="en-US" sz="1350" b="1" dirty="0">
+                <a:solidFill>
+                  <a:srgbClr val="B7431F"/>
+                </a:solidFill>
+                <a:latin typeface="Yu Gothic" pitchFamily="34" charset="0"/>
+                <a:ea typeface="Yu Gothic" pitchFamily="34" charset="-122"/>
+                <a:cs typeface="Yu Gothic" pitchFamily="34" charset="-120"/>
+              </a:rPr>
+              <a:t>収益に直結する「最優先」機能</a:t>
+            </a:r>
+            <a:pPr indent="0" marL="0">
+              <a:lnSpc>
+                <a:spcPct val="125000"/>
+              </a:lnSpc>
+              <a:buNone/>
+            </a:pPr>
+            <a:r>
+              <a:rPr lang="en-US" sz="1350" dirty="0">
+                <a:solidFill>
+                  <a:srgbClr val="17223B"/>
+                </a:solidFill>
+                <a:latin typeface="Yu Gothic" pitchFamily="34" charset="0"/>
+                <a:ea typeface="Yu Gothic" pitchFamily="34" charset="-122"/>
+                <a:cs typeface="Yu Gothic" pitchFamily="34" charset="-120"/>
+              </a:rPr>
+              <a:t>。スモールスタートの上に、この順で載せていくのがおすすめです。</a:t>
+            </a:r>
+            <a:endParaRPr lang="en-US" sz="1350" dirty="0"/>
+          </a:p>
+        </p:txBody>
+      </p:sp>
+    </p:spTree>
+  </p:cSld>
+  <p:clrMapOvr>
+    <a:masterClrMapping/>
+  </p:clrMapOvr>
+</p:sld>
+</file>
+
+<file path=ppt/slides/slide12.xml><?xml version="1.0" encoding="utf-8"?>
+<p:sld xmlns:a="http://schemas.openxmlformats.org/drawingml/2006/main" xmlns:r="http://schemas.openxmlformats.org/officeDocument/2006/relationships" xmlns:p="http://schemas.openxmlformats.org/presentationml/2006/main">
+  <p:cSld name="Slide 12">
     <p:bg>
       <p:bgPr>
         <a:solidFill>

</xml_diff>